<commit_message>
training: make slide typography portable
</commit_message>
<xml_diff>
--- a/training/slides/ai-agent-engineering-training.pptx
+++ b/training/slides/ai-agent-engineering-training.pptx
@@ -2,28 +2,28 @@
 <file path=ppt/presentation.xml><?xml version="1.0" encoding="utf-8"?>
 <p:presentation xmlns:p="http://schemas.openxmlformats.org/presentationml/2006/main">
   <p:sldMasterIdLst>
-    <p:sldMasterId xmlns:r="http://schemas.openxmlformats.org/officeDocument/2006/relationships" id="2147483648" r:id="Rc02554a9fc984413"/>
+    <p:sldMasterId xmlns:r="http://schemas.openxmlformats.org/officeDocument/2006/relationships" id="2147483648" r:id="R81b44344a1084a72"/>
   </p:sldMasterIdLst>
   <p:notesMasterIdLst>
-    <p:notesMasterId xmlns:r="http://schemas.openxmlformats.org/officeDocument/2006/relationships" r:id="R241e200a4f744ae7"/>
+    <p:notesMasterId xmlns:r="http://schemas.openxmlformats.org/officeDocument/2006/relationships" r:id="R1f8b09ddbdd24ff6"/>
   </p:notesMasterIdLst>
   <p:sldIdLst>
-    <p:sldId xmlns:r="http://schemas.openxmlformats.org/officeDocument/2006/relationships" id="256" r:id="Rb96e86d300bd4d26"/>
-    <p:sldId xmlns:r="http://schemas.openxmlformats.org/officeDocument/2006/relationships" id="257" r:id="Ra39418141da0435c"/>
-    <p:sldId xmlns:r="http://schemas.openxmlformats.org/officeDocument/2006/relationships" id="258" r:id="Rca49790d44ca4235"/>
-    <p:sldId xmlns:r="http://schemas.openxmlformats.org/officeDocument/2006/relationships" id="259" r:id="Rb55d8a38757e4359"/>
-    <p:sldId xmlns:r="http://schemas.openxmlformats.org/officeDocument/2006/relationships" id="260" r:id="Rc5a67f5a660c45a5"/>
-    <p:sldId xmlns:r="http://schemas.openxmlformats.org/officeDocument/2006/relationships" id="261" r:id="R6409e775f8564894"/>
-    <p:sldId xmlns:r="http://schemas.openxmlformats.org/officeDocument/2006/relationships" id="262" r:id="R6771d5366d154085"/>
-    <p:sldId xmlns:r="http://schemas.openxmlformats.org/officeDocument/2006/relationships" id="263" r:id="Rb7709877fbf94426"/>
-    <p:sldId xmlns:r="http://schemas.openxmlformats.org/officeDocument/2006/relationships" id="264" r:id="R1c70004c07ae4bd0"/>
-    <p:sldId xmlns:r="http://schemas.openxmlformats.org/officeDocument/2006/relationships" id="265" r:id="Rd019e52d30a44a7a"/>
-    <p:sldId xmlns:r="http://schemas.openxmlformats.org/officeDocument/2006/relationships" id="266" r:id="R028a3f4ebfec4bef"/>
-    <p:sldId xmlns:r="http://schemas.openxmlformats.org/officeDocument/2006/relationships" id="267" r:id="Re553ee45d98a479b"/>
-    <p:sldId xmlns:r="http://schemas.openxmlformats.org/officeDocument/2006/relationships" id="268" r:id="R18a4446394054e91"/>
-    <p:sldId xmlns:r="http://schemas.openxmlformats.org/officeDocument/2006/relationships" id="269" r:id="Rbf1a31f70d7b4fdd"/>
-    <p:sldId xmlns:r="http://schemas.openxmlformats.org/officeDocument/2006/relationships" id="270" r:id="Re305a8e8e26c43bc"/>
-    <p:sldId xmlns:r="http://schemas.openxmlformats.org/officeDocument/2006/relationships" id="271" r:id="R3069088a9ee2465b"/>
+    <p:sldId xmlns:r="http://schemas.openxmlformats.org/officeDocument/2006/relationships" id="256" r:id="Raa2c1fc89ad44556"/>
+    <p:sldId xmlns:r="http://schemas.openxmlformats.org/officeDocument/2006/relationships" id="257" r:id="R996fee3e9c494e0c"/>
+    <p:sldId xmlns:r="http://schemas.openxmlformats.org/officeDocument/2006/relationships" id="258" r:id="R306e904b31414cad"/>
+    <p:sldId xmlns:r="http://schemas.openxmlformats.org/officeDocument/2006/relationships" id="259" r:id="R93ec2098704b4f21"/>
+    <p:sldId xmlns:r="http://schemas.openxmlformats.org/officeDocument/2006/relationships" id="260" r:id="R4b0d6238af534ae2"/>
+    <p:sldId xmlns:r="http://schemas.openxmlformats.org/officeDocument/2006/relationships" id="261" r:id="Reaa476fd8ba542ec"/>
+    <p:sldId xmlns:r="http://schemas.openxmlformats.org/officeDocument/2006/relationships" id="262" r:id="R2040e8dc71964aca"/>
+    <p:sldId xmlns:r="http://schemas.openxmlformats.org/officeDocument/2006/relationships" id="263" r:id="Raaece47facac49a9"/>
+    <p:sldId xmlns:r="http://schemas.openxmlformats.org/officeDocument/2006/relationships" id="264" r:id="Rf2f0eb7ea8054e4c"/>
+    <p:sldId xmlns:r="http://schemas.openxmlformats.org/officeDocument/2006/relationships" id="265" r:id="R0a8f6440267f4b05"/>
+    <p:sldId xmlns:r="http://schemas.openxmlformats.org/officeDocument/2006/relationships" id="266" r:id="R5bf846d4b6ea4db1"/>
+    <p:sldId xmlns:r="http://schemas.openxmlformats.org/officeDocument/2006/relationships" id="267" r:id="Rf17fb6cc475a4cb9"/>
+    <p:sldId xmlns:r="http://schemas.openxmlformats.org/officeDocument/2006/relationships" id="268" r:id="R33c163bfc8984f7f"/>
+    <p:sldId xmlns:r="http://schemas.openxmlformats.org/officeDocument/2006/relationships" id="269" r:id="R67f39af8327348d0"/>
+    <p:sldId xmlns:r="http://schemas.openxmlformats.org/officeDocument/2006/relationships" id="270" r:id="R2a188ca6f81f4a0a"/>
+    <p:sldId xmlns:r="http://schemas.openxmlformats.org/officeDocument/2006/relationships" id="271" r:id="R0867cced1d9b43df"/>
   </p:sldIdLst>
   <p:sldSz cx="12192000" cy="6858000"/>
   <p:notesSz cx="6858000" cy="9144000"/>
@@ -1895,7 +1895,7 @@
   </p:cSld>
   <p:clrMap bg1="lt1" tx1="dk1" bg2="lt2" tx2="dk2" accent1="accent1" accent2="accent2" accent3="accent3" accent4="accent4" accent5="accent5" accent6="accent6" hlink="hlink" folHlink="folHlink"/>
   <p:sldLayoutIdLst>
-    <p:sldLayoutId xmlns:r="http://schemas.openxmlformats.org/officeDocument/2006/relationships" id="2147483649" r:id="R28d6eaa211404ae1"/>
+    <p:sldLayoutId xmlns:r="http://schemas.openxmlformats.org/officeDocument/2006/relationships" id="2147483649" r:id="Rd779ab9665cc4939"/>
   </p:sldLayoutIdLst>
   <p:txStyles>
     <p:titleStyle>
@@ -2464,16 +2464,25 @@
           <a:lstStyle xmlns:a="http://schemas.openxmlformats.org/drawingml/2006/main"/>
           <a:p xmlns:a="http://schemas.openxmlformats.org/drawingml/2006/main">
             <a:pPr algn="l">
+              <a:buNone/>
               <a:defRPr sz="6000">
                 <a:solidFill>
                   <a:srgbClr val="000000"/>
                 </a:solidFill>
-                <a:latin typeface="Helvetica Neue"/>
-                <a:ea typeface="Helvetica Neue"/>
-                <a:cs typeface="Helvetica Neue"/>
-              </a:defRPr>
-            </a:pPr>
-            <a:r>
+                <a:latin typeface="Noto Sans SC"/>
+                <a:ea typeface="Noto Sans SC"/>
+                <a:cs typeface="Noto Sans SC"/>
+              </a:defRPr>
+            </a:pPr>
+            <a:r>
+              <a:rPr sz="6000">
+                <a:solidFill>
+                  <a:srgbClr val="000000"/>
+                </a:solidFill>
+                <a:latin typeface="Noto Sans SC"/>
+                <a:ea typeface="Noto Sans SC"/>
+                <a:cs typeface="Noto Sans SC"/>
+              </a:rPr>
               <a:t>从模型能力
 到可靠系统</a:t>
             </a:r>
@@ -2510,16 +2519,25 @@
           <a:lstStyle xmlns:a="http://schemas.openxmlformats.org/drawingml/2006/main"/>
           <a:p xmlns:a="http://schemas.openxmlformats.org/drawingml/2006/main">
             <a:pPr algn="l">
+              <a:buNone/>
               <a:defRPr sz="2400">
                 <a:solidFill>
                   <a:srgbClr val="000000"/>
                 </a:solidFill>
-                <a:latin typeface="Helvetica Neue"/>
-                <a:ea typeface="Helvetica Neue"/>
-                <a:cs typeface="Helvetica Neue"/>
-              </a:defRPr>
-            </a:pPr>
-            <a:r>
+                <a:latin typeface="Noto Sans SC"/>
+                <a:ea typeface="Noto Sans SC"/>
+                <a:cs typeface="Noto Sans SC"/>
+              </a:defRPr>
+            </a:pPr>
+            <a:r>
+              <a:rPr sz="2400">
+                <a:solidFill>
+                  <a:srgbClr val="000000"/>
+                </a:solidFill>
+                <a:latin typeface="Noto Sans SC"/>
+                <a:ea typeface="Noto Sans SC"/>
+                <a:cs typeface="Noto Sans SC"/>
+              </a:rPr>
               <a:t>原理、工程、评估与项目实践</a:t>
             </a:r>
           </a:p>
@@ -2555,16 +2573,25 @@
           <a:lstStyle xmlns:a="http://schemas.openxmlformats.org/drawingml/2006/main"/>
           <a:p xmlns:a="http://schemas.openxmlformats.org/drawingml/2006/main">
             <a:pPr algn="l">
+              <a:buNone/>
               <a:defRPr sz="2400">
                 <a:solidFill>
                   <a:srgbClr val="000000"/>
                 </a:solidFill>
-                <a:latin typeface="Helvetica Neue"/>
-                <a:ea typeface="Helvetica Neue"/>
-                <a:cs typeface="Helvetica Neue"/>
-              </a:defRPr>
-            </a:pPr>
-            <a:r>
+                <a:latin typeface="Noto Sans SC"/>
+                <a:ea typeface="Noto Sans SC"/>
+                <a:cs typeface="Noto Sans SC"/>
+              </a:defRPr>
+            </a:pPr>
+            <a:r>
+              <a:rPr sz="2400">
+                <a:solidFill>
+                  <a:srgbClr val="000000"/>
+                </a:solidFill>
+                <a:latin typeface="Noto Sans SC"/>
+                <a:ea typeface="Noto Sans SC"/>
+                <a:cs typeface="Noto Sans SC"/>
+              </a:rPr>
               <a:t>AI AGENT 工程课程</a:t>
             </a:r>
           </a:p>
@@ -2622,16 +2649,25 @@
           <a:lstStyle xmlns:a="http://schemas.openxmlformats.org/drawingml/2006/main"/>
           <a:p xmlns:a="http://schemas.openxmlformats.org/drawingml/2006/main">
             <a:pPr algn="r">
+              <a:buNone/>
               <a:defRPr sz="1000">
                 <a:solidFill>
                   <a:srgbClr val="000000"/>
                 </a:solidFill>
-                <a:latin typeface="Helvetica Neue"/>
-                <a:ea typeface="Helvetica Neue"/>
-                <a:cs typeface="Helvetica Neue"/>
-              </a:defRPr>
-            </a:pPr>
-            <a:r>
+                <a:latin typeface="Noto Sans SC"/>
+                <a:ea typeface="Noto Sans SC"/>
+                <a:cs typeface="Noto Sans SC"/>
+              </a:defRPr>
+            </a:pPr>
+            <a:r>
+              <a:rPr sz="1000">
+                <a:solidFill>
+                  <a:srgbClr val="000000"/>
+                </a:solidFill>
+                <a:latin typeface="Noto Sans SC"/>
+                <a:ea typeface="Noto Sans SC"/>
+                <a:cs typeface="Noto Sans SC"/>
+              </a:rPr>
               <a:t>10</a:t>
             </a:r>
           </a:p>
@@ -2667,16 +2703,25 @@
           <a:lstStyle xmlns:a="http://schemas.openxmlformats.org/drawingml/2006/main"/>
           <a:p xmlns:a="http://schemas.openxmlformats.org/drawingml/2006/main">
             <a:pPr algn="l">
+              <a:buNone/>
               <a:defRPr sz="2900">
                 <a:solidFill>
                   <a:srgbClr val="000000"/>
                 </a:solidFill>
-                <a:latin typeface="Helvetica Neue"/>
-                <a:ea typeface="Helvetica Neue"/>
-                <a:cs typeface="Helvetica Neue"/>
-              </a:defRPr>
-            </a:pPr>
-            <a:r>
+                <a:latin typeface="Noto Sans SC"/>
+                <a:ea typeface="Noto Sans SC"/>
+                <a:cs typeface="Noto Sans SC"/>
+              </a:defRPr>
+            </a:pPr>
+            <a:r>
+              <a:rPr sz="2900">
+                <a:solidFill>
+                  <a:srgbClr val="000000"/>
+                </a:solidFill>
+                <a:latin typeface="Noto Sans SC"/>
+                <a:ea typeface="Noto Sans SC"/>
+                <a:cs typeface="Noto Sans SC"/>
+              </a:rPr>
               <a:t>框架选型从控制需求开始</a:t>
             </a:r>
           </a:p>
@@ -2712,31 +2757,49 @@
           <a:lstStyle xmlns:a="http://schemas.openxmlformats.org/drawingml/2006/main"/>
           <a:p xmlns:a="http://schemas.openxmlformats.org/drawingml/2006/main">
             <a:pPr algn="l">
+              <a:buNone/>
               <a:defRPr sz="2400">
                 <a:solidFill>
                   <a:srgbClr val="000000"/>
                 </a:solidFill>
-                <a:latin typeface="Helvetica Neue"/>
-                <a:ea typeface="Helvetica Neue"/>
-                <a:cs typeface="Helvetica Neue"/>
-              </a:defRPr>
-            </a:pPr>
-            <a:r>
+                <a:latin typeface="Noto Sans SC"/>
+                <a:ea typeface="Noto Sans SC"/>
+                <a:cs typeface="Noto Sans SC"/>
+              </a:defRPr>
+            </a:pPr>
+            <a:r>
+              <a:rPr sz="2400">
+                <a:solidFill>
+                  <a:srgbClr val="000000"/>
+                </a:solidFill>
+                <a:latin typeface="Noto Sans SC"/>
+                <a:ea typeface="Noto Sans SC"/>
+                <a:cs typeface="Noto Sans SC"/>
+              </a:rPr>
               <a:t>原生接口</a:t>
             </a:r>
           </a:p>
           <a:p xmlns:a="http://schemas.openxmlformats.org/drawingml/2006/main">
             <a:pPr algn="l">
+              <a:buNone/>
               <a:defRPr sz="2400">
                 <a:solidFill>
                   <a:srgbClr val="000000"/>
                 </a:solidFill>
-                <a:latin typeface="Helvetica Neue"/>
-                <a:ea typeface="Helvetica Neue"/>
-                <a:cs typeface="Helvetica Neue"/>
-              </a:defRPr>
-            </a:pPr>
-            <a:r>
+                <a:latin typeface="Noto Sans SC"/>
+                <a:ea typeface="Noto Sans SC"/>
+                <a:cs typeface="Noto Sans SC"/>
+              </a:defRPr>
+            </a:pPr>
+            <a:r>
+              <a:rPr sz="2400">
+                <a:solidFill>
+                  <a:srgbClr val="000000"/>
+                </a:solidFill>
+                <a:latin typeface="Noto Sans SC"/>
+                <a:ea typeface="Noto Sans SC"/>
+                <a:cs typeface="Noto Sans SC"/>
+              </a:rPr>
               <a:t>
 透明可控；适合学习机制。</a:t>
             </a:r>
@@ -2773,31 +2836,49 @@
           <a:lstStyle xmlns:a="http://schemas.openxmlformats.org/drawingml/2006/main"/>
           <a:p xmlns:a="http://schemas.openxmlformats.org/drawingml/2006/main">
             <a:pPr algn="l">
+              <a:buNone/>
               <a:defRPr sz="2400">
                 <a:solidFill>
                   <a:srgbClr val="000000"/>
                 </a:solidFill>
-                <a:latin typeface="Helvetica Neue"/>
-                <a:ea typeface="Helvetica Neue"/>
-                <a:cs typeface="Helvetica Neue"/>
-              </a:defRPr>
-            </a:pPr>
-            <a:r>
+                <a:latin typeface="Noto Sans SC"/>
+                <a:ea typeface="Noto Sans SC"/>
+                <a:cs typeface="Noto Sans SC"/>
+              </a:defRPr>
+            </a:pPr>
+            <a:r>
+              <a:rPr sz="2400">
+                <a:solidFill>
+                  <a:srgbClr val="000000"/>
+                </a:solidFill>
+                <a:latin typeface="Noto Sans SC"/>
+                <a:ea typeface="Noto Sans SC"/>
+                <a:cs typeface="Noto Sans SC"/>
+              </a:rPr>
               <a:t>图式工作流</a:t>
             </a:r>
           </a:p>
           <a:p xmlns:a="http://schemas.openxmlformats.org/drawingml/2006/main">
             <a:pPr algn="l">
+              <a:buNone/>
               <a:defRPr sz="2400">
                 <a:solidFill>
                   <a:srgbClr val="000000"/>
                 </a:solidFill>
-                <a:latin typeface="Helvetica Neue"/>
-                <a:ea typeface="Helvetica Neue"/>
-                <a:cs typeface="Helvetica Neue"/>
-              </a:defRPr>
-            </a:pPr>
-            <a:r>
+                <a:latin typeface="Noto Sans SC"/>
+                <a:ea typeface="Noto Sans SC"/>
+                <a:cs typeface="Noto Sans SC"/>
+              </a:defRPr>
+            </a:pPr>
+            <a:r>
+              <a:rPr sz="2400">
+                <a:solidFill>
+                  <a:srgbClr val="000000"/>
+                </a:solidFill>
+                <a:latin typeface="Noto Sans SC"/>
+                <a:ea typeface="Noto Sans SC"/>
+                <a:cs typeface="Noto Sans SC"/>
+              </a:rPr>
               <a:t>
 适合持久状态与复杂路由。</a:t>
             </a:r>
@@ -2834,31 +2915,49 @@
           <a:lstStyle xmlns:a="http://schemas.openxmlformats.org/drawingml/2006/main"/>
           <a:p xmlns:a="http://schemas.openxmlformats.org/drawingml/2006/main">
             <a:pPr algn="l">
+              <a:buNone/>
               <a:defRPr sz="2400">
                 <a:solidFill>
                   <a:srgbClr val="000000"/>
                 </a:solidFill>
-                <a:latin typeface="Helvetica Neue"/>
-                <a:ea typeface="Helvetica Neue"/>
-                <a:cs typeface="Helvetica Neue"/>
-              </a:defRPr>
-            </a:pPr>
-            <a:r>
+                <a:latin typeface="Noto Sans SC"/>
+                <a:ea typeface="Noto Sans SC"/>
+                <a:cs typeface="Noto Sans SC"/>
+              </a:defRPr>
+            </a:pPr>
+            <a:r>
+              <a:rPr sz="2400">
+                <a:solidFill>
+                  <a:srgbClr val="000000"/>
+                </a:solidFill>
+                <a:latin typeface="Noto Sans SC"/>
+                <a:ea typeface="Noto Sans SC"/>
+                <a:cs typeface="Noto Sans SC"/>
+              </a:rPr>
               <a:t>类型化运行时</a:t>
             </a:r>
           </a:p>
           <a:p xmlns:a="http://schemas.openxmlformats.org/drawingml/2006/main">
             <a:pPr algn="l">
+              <a:buNone/>
               <a:defRPr sz="2400">
                 <a:solidFill>
                   <a:srgbClr val="000000"/>
                 </a:solidFill>
-                <a:latin typeface="Helvetica Neue"/>
-                <a:ea typeface="Helvetica Neue"/>
-                <a:cs typeface="Helvetica Neue"/>
-              </a:defRPr>
-            </a:pPr>
-            <a:r>
+                <a:latin typeface="Noto Sans SC"/>
+                <a:ea typeface="Noto Sans SC"/>
+                <a:cs typeface="Noto Sans SC"/>
+              </a:defRPr>
+            </a:pPr>
+            <a:r>
+              <a:rPr sz="2400">
+                <a:solidFill>
+                  <a:srgbClr val="000000"/>
+                </a:solidFill>
+                <a:latin typeface="Noto Sans SC"/>
+                <a:ea typeface="Noto Sans SC"/>
+                <a:cs typeface="Noto Sans SC"/>
+              </a:rPr>
               <a:t>
 适合工具、输出与服务边界。</a:t>
             </a:r>
@@ -3002,16 +3101,25 @@
           <a:lstStyle xmlns:a="http://schemas.openxmlformats.org/drawingml/2006/main"/>
           <a:p xmlns:a="http://schemas.openxmlformats.org/drawingml/2006/main">
             <a:pPr algn="r">
+              <a:buNone/>
               <a:defRPr sz="1000">
                 <a:solidFill>
                   <a:srgbClr val="000000"/>
                 </a:solidFill>
-                <a:latin typeface="Helvetica Neue"/>
-                <a:ea typeface="Helvetica Neue"/>
-                <a:cs typeface="Helvetica Neue"/>
-              </a:defRPr>
-            </a:pPr>
-            <a:r>
+                <a:latin typeface="Noto Sans SC"/>
+                <a:ea typeface="Noto Sans SC"/>
+                <a:cs typeface="Noto Sans SC"/>
+              </a:defRPr>
+            </a:pPr>
+            <a:r>
+              <a:rPr sz="1000">
+                <a:solidFill>
+                  <a:srgbClr val="000000"/>
+                </a:solidFill>
+                <a:latin typeface="Noto Sans SC"/>
+                <a:ea typeface="Noto Sans SC"/>
+                <a:cs typeface="Noto Sans SC"/>
+              </a:rPr>
               <a:t>11</a:t>
             </a:r>
           </a:p>
@@ -3047,16 +3155,25 @@
           <a:lstStyle xmlns:a="http://schemas.openxmlformats.org/drawingml/2006/main"/>
           <a:p xmlns:a="http://schemas.openxmlformats.org/drawingml/2006/main">
             <a:pPr algn="l">
+              <a:buNone/>
               <a:defRPr sz="2900">
                 <a:solidFill>
                   <a:srgbClr val="000000"/>
                 </a:solidFill>
-                <a:latin typeface="Helvetica Neue"/>
-                <a:ea typeface="Helvetica Neue"/>
-                <a:cs typeface="Helvetica Neue"/>
-              </a:defRPr>
-            </a:pPr>
-            <a:r>
+                <a:latin typeface="Noto Sans SC"/>
+                <a:ea typeface="Noto Sans SC"/>
+                <a:cs typeface="Noto Sans SC"/>
+              </a:defRPr>
+            </a:pPr>
+            <a:r>
+              <a:rPr sz="2900">
+                <a:solidFill>
+                  <a:srgbClr val="000000"/>
+                </a:solidFill>
+                <a:latin typeface="Noto Sans SC"/>
+                <a:ea typeface="Noto Sans SC"/>
+                <a:cs typeface="Noto Sans SC"/>
+              </a:rPr>
               <a:t>生产就绪必须由证据证明</a:t>
             </a:r>
           </a:p>
@@ -3092,16 +3209,25 @@
           <a:lstStyle xmlns:a="http://schemas.openxmlformats.org/drawingml/2006/main"/>
           <a:p xmlns:a="http://schemas.openxmlformats.org/drawingml/2006/main">
             <a:pPr algn="l">
+              <a:buNone/>
               <a:defRPr sz="2400">
                 <a:solidFill>
                   <a:srgbClr val="000000"/>
                 </a:solidFill>
-                <a:latin typeface="Helvetica Neue"/>
-                <a:ea typeface="Helvetica Neue"/>
-                <a:cs typeface="Helvetica Neue"/>
-              </a:defRPr>
-            </a:pPr>
-            <a:r>
+                <a:latin typeface="Noto Sans SC"/>
+                <a:ea typeface="Noto Sans SC"/>
+                <a:cs typeface="Noto Sans SC"/>
+              </a:defRPr>
+            </a:pPr>
+            <a:r>
+              <a:rPr sz="2400">
+                <a:solidFill>
+                  <a:srgbClr val="000000"/>
+                </a:solidFill>
+                <a:latin typeface="Noto Sans SC"/>
+                <a:ea typeface="Noto Sans SC"/>
+                <a:cs typeface="Noto Sans SC"/>
+              </a:rPr>
               <a:t>成功、边界、攻击与回归</a:t>
             </a:r>
           </a:p>
@@ -3137,16 +3263,25 @@
           <a:lstStyle xmlns:a="http://schemas.openxmlformats.org/drawingml/2006/main"/>
           <a:p xmlns:a="http://schemas.openxmlformats.org/drawingml/2006/main">
             <a:pPr algn="l">
+              <a:buNone/>
               <a:defRPr sz="2400">
                 <a:solidFill>
                   <a:srgbClr val="000000"/>
                 </a:solidFill>
-                <a:latin typeface="Helvetica Neue"/>
-                <a:ea typeface="Helvetica Neue"/>
-                <a:cs typeface="Helvetica Neue"/>
-              </a:defRPr>
-            </a:pPr>
-            <a:r>
+                <a:latin typeface="Noto Sans SC"/>
+                <a:ea typeface="Noto Sans SC"/>
+                <a:cs typeface="Noto Sans SC"/>
+              </a:defRPr>
+            </a:pPr>
+            <a:r>
+              <a:rPr sz="2400">
+                <a:solidFill>
+                  <a:srgbClr val="000000"/>
+                </a:solidFill>
+                <a:latin typeface="Noto Sans SC"/>
+                <a:ea typeface="Noto Sans SC"/>
+                <a:cs typeface="Noto Sans SC"/>
+              </a:rPr>
               <a:t>重试、幂等、DLQ 与回滚</a:t>
             </a:r>
           </a:p>
@@ -3182,16 +3317,25 @@
           <a:lstStyle xmlns:a="http://schemas.openxmlformats.org/drawingml/2006/main"/>
           <a:p xmlns:a="http://schemas.openxmlformats.org/drawingml/2006/main">
             <a:pPr algn="l">
+              <a:buNone/>
               <a:defRPr sz="2400">
                 <a:solidFill>
                   <a:srgbClr val="000000"/>
                 </a:solidFill>
-                <a:latin typeface="Helvetica Neue"/>
-                <a:ea typeface="Helvetica Neue"/>
-                <a:cs typeface="Helvetica Neue"/>
-              </a:defRPr>
-            </a:pPr>
-            <a:r>
+                <a:latin typeface="Noto Sans SC"/>
+                <a:ea typeface="Noto Sans SC"/>
+                <a:cs typeface="Noto Sans SC"/>
+              </a:defRPr>
+            </a:pPr>
+            <a:r>
+              <a:rPr sz="2400">
+                <a:solidFill>
+                  <a:srgbClr val="000000"/>
+                </a:solidFill>
+                <a:latin typeface="Noto Sans SC"/>
+                <a:ea typeface="Noto Sans SC"/>
+                <a:cs typeface="Noto Sans SC"/>
+              </a:rPr>
               <a:t>状态、工具、检索与成本</a:t>
             </a:r>
           </a:p>
@@ -3227,16 +3371,25 @@
           <a:lstStyle xmlns:a="http://schemas.openxmlformats.org/drawingml/2006/main"/>
           <a:p xmlns:a="http://schemas.openxmlformats.org/drawingml/2006/main">
             <a:pPr algn="l">
+              <a:buNone/>
               <a:defRPr sz="2400">
                 <a:solidFill>
                   <a:srgbClr val="000000"/>
                 </a:solidFill>
-                <a:latin typeface="Helvetica Neue"/>
-                <a:ea typeface="Helvetica Neue"/>
-                <a:cs typeface="Helvetica Neue"/>
-              </a:defRPr>
-            </a:pPr>
-            <a:r>
+                <a:latin typeface="Noto Sans SC"/>
+                <a:ea typeface="Noto Sans SC"/>
+                <a:cs typeface="Noto Sans SC"/>
+              </a:defRPr>
+            </a:pPr>
+            <a:r>
+              <a:rPr sz="2400">
+                <a:solidFill>
+                  <a:srgbClr val="000000"/>
+                </a:solidFill>
+                <a:latin typeface="Noto Sans SC"/>
+                <a:ea typeface="Noto Sans SC"/>
+                <a:cs typeface="Noto Sans SC"/>
+              </a:rPr>
               <a:t>测试</a:t>
             </a:r>
           </a:p>
@@ -3272,16 +3425,25 @@
           <a:lstStyle xmlns:a="http://schemas.openxmlformats.org/drawingml/2006/main"/>
           <a:p xmlns:a="http://schemas.openxmlformats.org/drawingml/2006/main">
             <a:pPr algn="l">
+              <a:buNone/>
               <a:defRPr sz="2400">
                 <a:solidFill>
                   <a:srgbClr val="000000"/>
                 </a:solidFill>
-                <a:latin typeface="Helvetica Neue"/>
-                <a:ea typeface="Helvetica Neue"/>
-                <a:cs typeface="Helvetica Neue"/>
-              </a:defRPr>
-            </a:pPr>
-            <a:r>
+                <a:latin typeface="Noto Sans SC"/>
+                <a:ea typeface="Noto Sans SC"/>
+                <a:cs typeface="Noto Sans SC"/>
+              </a:defRPr>
+            </a:pPr>
+            <a:r>
+              <a:rPr sz="2400">
+                <a:solidFill>
+                  <a:srgbClr val="000000"/>
+                </a:solidFill>
+                <a:latin typeface="Noto Sans SC"/>
+                <a:ea typeface="Noto Sans SC"/>
+                <a:cs typeface="Noto Sans SC"/>
+              </a:rPr>
               <a:t>Trace</a:t>
             </a:r>
           </a:p>
@@ -3317,16 +3479,25 @@
           <a:lstStyle xmlns:a="http://schemas.openxmlformats.org/drawingml/2006/main"/>
           <a:p xmlns:a="http://schemas.openxmlformats.org/drawingml/2006/main">
             <a:pPr algn="l">
+              <a:buNone/>
               <a:defRPr sz="2400">
                 <a:solidFill>
                   <a:srgbClr val="000000"/>
                 </a:solidFill>
-                <a:latin typeface="Helvetica Neue"/>
-                <a:ea typeface="Helvetica Neue"/>
-                <a:cs typeface="Helvetica Neue"/>
-              </a:defRPr>
-            </a:pPr>
-            <a:r>
+                <a:latin typeface="Noto Sans SC"/>
+                <a:ea typeface="Noto Sans SC"/>
+                <a:cs typeface="Noto Sans SC"/>
+              </a:defRPr>
+            </a:pPr>
+            <a:r>
+              <a:rPr sz="2400">
+                <a:solidFill>
+                  <a:srgbClr val="000000"/>
+                </a:solidFill>
+                <a:latin typeface="Noto Sans SC"/>
+                <a:ea typeface="Noto Sans SC"/>
+                <a:cs typeface="Noto Sans SC"/>
+              </a:rPr>
               <a:t>恢复</a:t>
             </a:r>
           </a:p>
@@ -3362,31 +3533,49 @@
           <a:lstStyle xmlns:a="http://schemas.openxmlformats.org/drawingml/2006/main"/>
           <a:p xmlns:a="http://schemas.openxmlformats.org/drawingml/2006/main">
             <a:pPr algn="l">
+              <a:buNone/>
               <a:defRPr sz="1600">
                 <a:solidFill>
                   <a:srgbClr val="000000"/>
                 </a:solidFill>
-                <a:latin typeface="Helvetica Neue"/>
-                <a:ea typeface="Helvetica Neue"/>
-                <a:cs typeface="Helvetica Neue"/>
-              </a:defRPr>
-            </a:pPr>
-            <a:r>
+                <a:latin typeface="Noto Sans SC"/>
+                <a:ea typeface="Noto Sans SC"/>
+                <a:cs typeface="Noto Sans SC"/>
+              </a:defRPr>
+            </a:pPr>
+            <a:r>
+              <a:rPr sz="1600">
+                <a:solidFill>
+                  <a:srgbClr val="000000"/>
+                </a:solidFill>
+                <a:latin typeface="Noto Sans SC"/>
+                <a:ea typeface="Noto Sans SC"/>
+                <a:cs typeface="Noto Sans SC"/>
+              </a:rPr>
               <a:t>三个不可替代的证据面</a:t>
             </a:r>
           </a:p>
           <a:p xmlns:a="http://schemas.openxmlformats.org/drawingml/2006/main">
             <a:pPr algn="l">
+              <a:buNone/>
               <a:defRPr sz="1600">
                 <a:solidFill>
                   <a:srgbClr val="000000"/>
                 </a:solidFill>
-                <a:latin typeface="Helvetica Neue"/>
-                <a:ea typeface="Helvetica Neue"/>
-                <a:cs typeface="Helvetica Neue"/>
-              </a:defRPr>
-            </a:pPr>
-            <a:r>
+                <a:latin typeface="Noto Sans SC"/>
+                <a:ea typeface="Noto Sans SC"/>
+                <a:cs typeface="Noto Sans SC"/>
+              </a:defRPr>
+            </a:pPr>
+            <a:r>
+              <a:rPr sz="1600">
+                <a:solidFill>
+                  <a:srgbClr val="000000"/>
+                </a:solidFill>
+                <a:latin typeface="Noto Sans SC"/>
+                <a:ea typeface="Noto Sans SC"/>
+                <a:cs typeface="Noto Sans SC"/>
+              </a:rPr>
               <a:t>
 功能演示只能说明某次成功；测试、观测和恢复共同说明系统可运营。</a:t>
             </a:r>
@@ -3443,16 +3632,25 @@
           <a:lstStyle xmlns:a="http://schemas.openxmlformats.org/drawingml/2006/main"/>
           <a:p xmlns:a="http://schemas.openxmlformats.org/drawingml/2006/main">
             <a:pPr algn="r">
+              <a:buNone/>
               <a:defRPr sz="1000">
                 <a:solidFill>
                   <a:srgbClr val="000000"/>
                 </a:solidFill>
-                <a:latin typeface="Helvetica Neue"/>
-                <a:ea typeface="Helvetica Neue"/>
-                <a:cs typeface="Helvetica Neue"/>
-              </a:defRPr>
-            </a:pPr>
-            <a:r>
+                <a:latin typeface="Noto Sans SC"/>
+                <a:ea typeface="Noto Sans SC"/>
+                <a:cs typeface="Noto Sans SC"/>
+              </a:defRPr>
+            </a:pPr>
+            <a:r>
+              <a:rPr sz="1000">
+                <a:solidFill>
+                  <a:srgbClr val="000000"/>
+                </a:solidFill>
+                <a:latin typeface="Noto Sans SC"/>
+                <a:ea typeface="Noto Sans SC"/>
+                <a:cs typeface="Noto Sans SC"/>
+              </a:rPr>
               <a:t>12</a:t>
             </a:r>
           </a:p>
@@ -3488,16 +3686,25 @@
           <a:lstStyle xmlns:a="http://schemas.openxmlformats.org/drawingml/2006/main"/>
           <a:p xmlns:a="http://schemas.openxmlformats.org/drawingml/2006/main">
             <a:pPr algn="l">
+              <a:buNone/>
               <a:defRPr sz="2900">
                 <a:solidFill>
                   <a:srgbClr val="000000"/>
                 </a:solidFill>
-                <a:latin typeface="Helvetica Neue"/>
-                <a:ea typeface="Helvetica Neue"/>
-                <a:cs typeface="Helvetica Neue"/>
-              </a:defRPr>
-            </a:pPr>
-            <a:r>
+                <a:latin typeface="Noto Sans SC"/>
+                <a:ea typeface="Noto Sans SC"/>
+                <a:cs typeface="Noto Sans SC"/>
+              </a:defRPr>
+            </a:pPr>
+            <a:r>
+              <a:rPr sz="2900">
+                <a:solidFill>
+                  <a:srgbClr val="000000"/>
+                </a:solidFill>
+                <a:latin typeface="Noto Sans SC"/>
+                <a:ea typeface="Noto Sans SC"/>
+                <a:cs typeface="Noto Sans SC"/>
+              </a:rPr>
               <a:t>Prompt Injection 是权限问题，不只是文本问题</a:t>
             </a:r>
           </a:p>
@@ -3505,7 +3712,7 @@
       </p:sp>
       <p:cxnSp>
         <p:nvCxnSpPr>
-          <p:cNvPr id="18" name="Google-Shape-2259-p159-4"/>
+          <p:cNvPr id="24" name="Google-Shape-2259-p159-4"/>
           <p:cNvCxnSpPr/>
           <p:nvPr/>
         </p:nvCxnSpPr>
@@ -3665,31 +3872,49 @@
           <a:lstStyle xmlns:a="http://schemas.openxmlformats.org/drawingml/2006/main"/>
           <a:p xmlns:a="http://schemas.openxmlformats.org/drawingml/2006/main">
             <a:pPr algn="l">
+              <a:buNone/>
               <a:defRPr sz="1600">
                 <a:solidFill>
                   <a:srgbClr val="000000"/>
                 </a:solidFill>
-                <a:latin typeface="Helvetica Neue"/>
-                <a:ea typeface="Helvetica Neue"/>
-                <a:cs typeface="Helvetica Neue"/>
-              </a:defRPr>
-            </a:pPr>
-            <a:r>
+                <a:latin typeface="Noto Sans SC"/>
+                <a:ea typeface="Noto Sans SC"/>
+                <a:cs typeface="Noto Sans SC"/>
+              </a:defRPr>
+            </a:pPr>
+            <a:r>
+              <a:rPr sz="1600">
+                <a:solidFill>
+                  <a:srgbClr val="000000"/>
+                </a:solidFill>
+                <a:latin typeface="Noto Sans SC"/>
+                <a:ea typeface="Noto Sans SC"/>
+                <a:cs typeface="Noto Sans SC"/>
+              </a:rPr>
               <a:t>缩小能力</a:t>
             </a:r>
           </a:p>
           <a:p xmlns:a="http://schemas.openxmlformats.org/drawingml/2006/main">
             <a:pPr algn="l">
+              <a:buNone/>
               <a:defRPr sz="1600">
                 <a:solidFill>
                   <a:srgbClr val="000000"/>
                 </a:solidFill>
-                <a:latin typeface="Helvetica Neue"/>
-                <a:ea typeface="Helvetica Neue"/>
-                <a:cs typeface="Helvetica Neue"/>
-              </a:defRPr>
-            </a:pPr>
-            <a:r>
+                <a:latin typeface="Noto Sans SC"/>
+                <a:ea typeface="Noto Sans SC"/>
+                <a:cs typeface="Noto Sans SC"/>
+              </a:defRPr>
+            </a:pPr>
+            <a:r>
+              <a:rPr sz="1600">
+                <a:solidFill>
+                  <a:srgbClr val="000000"/>
+                </a:solidFill>
+                <a:latin typeface="Noto Sans SC"/>
+                <a:ea typeface="Noto Sans SC"/>
+                <a:cs typeface="Noto Sans SC"/>
+              </a:rPr>
               <a:t>
 最小权限、来源隔离、数据/指令分离、审批</a:t>
             </a:r>
@@ -3755,31 +3980,49 @@
           <a:lstStyle xmlns:a="http://schemas.openxmlformats.org/drawingml/2006/main"/>
           <a:p xmlns:a="http://schemas.openxmlformats.org/drawingml/2006/main">
             <a:pPr algn="l">
+              <a:buNone/>
               <a:defRPr sz="1600">
                 <a:solidFill>
                   <a:srgbClr val="000000"/>
                 </a:solidFill>
-                <a:latin typeface="Helvetica Neue"/>
-                <a:ea typeface="Helvetica Neue"/>
-                <a:cs typeface="Helvetica Neue"/>
-              </a:defRPr>
-            </a:pPr>
-            <a:r>
+                <a:latin typeface="Noto Sans SC"/>
+                <a:ea typeface="Noto Sans SC"/>
+                <a:cs typeface="Noto Sans SC"/>
+              </a:defRPr>
+            </a:pPr>
+            <a:r>
+              <a:rPr sz="1600">
+                <a:solidFill>
+                  <a:srgbClr val="000000"/>
+                </a:solidFill>
+                <a:latin typeface="Noto Sans SC"/>
+                <a:ea typeface="Noto Sans SC"/>
+                <a:cs typeface="Noto Sans SC"/>
+              </a:rPr>
               <a:t>发现异常</a:t>
             </a:r>
           </a:p>
           <a:p xmlns:a="http://schemas.openxmlformats.org/drawingml/2006/main">
             <a:pPr algn="l">
+              <a:buNone/>
               <a:defRPr sz="1600">
                 <a:solidFill>
                   <a:srgbClr val="000000"/>
                 </a:solidFill>
-                <a:latin typeface="Helvetica Neue"/>
-                <a:ea typeface="Helvetica Neue"/>
-                <a:cs typeface="Helvetica Neue"/>
-              </a:defRPr>
-            </a:pPr>
-            <a:r>
+                <a:latin typeface="Noto Sans SC"/>
+                <a:ea typeface="Noto Sans SC"/>
+                <a:cs typeface="Noto Sans SC"/>
+              </a:defRPr>
+            </a:pPr>
+            <a:r>
+              <a:rPr sz="1600">
+                <a:solidFill>
+                  <a:srgbClr val="000000"/>
+                </a:solidFill>
+                <a:latin typeface="Noto Sans SC"/>
+                <a:ea typeface="Noto Sans SC"/>
+                <a:cs typeface="Noto Sans SC"/>
+              </a:rPr>
               <a:t>
 攻击 Fixture、工具偏差、外传信号、审计告警</a:t>
             </a:r>
@@ -3845,31 +4088,49 @@
           <a:lstStyle xmlns:a="http://schemas.openxmlformats.org/drawingml/2006/main"/>
           <a:p xmlns:a="http://schemas.openxmlformats.org/drawingml/2006/main">
             <a:pPr algn="l">
+              <a:buNone/>
               <a:defRPr sz="1600">
                 <a:solidFill>
                   <a:srgbClr val="000000"/>
                 </a:solidFill>
-                <a:latin typeface="Helvetica Neue"/>
-                <a:ea typeface="Helvetica Neue"/>
-                <a:cs typeface="Helvetica Neue"/>
-              </a:defRPr>
-            </a:pPr>
-            <a:r>
+                <a:latin typeface="Noto Sans SC"/>
+                <a:ea typeface="Noto Sans SC"/>
+                <a:cs typeface="Noto Sans SC"/>
+              </a:defRPr>
+            </a:pPr>
+            <a:r>
+              <a:rPr sz="1600">
+                <a:solidFill>
+                  <a:srgbClr val="000000"/>
+                </a:solidFill>
+                <a:latin typeface="Noto Sans SC"/>
+                <a:ea typeface="Noto Sans SC"/>
+                <a:cs typeface="Noto Sans SC"/>
+              </a:rPr>
               <a:t>限制影响</a:t>
             </a:r>
           </a:p>
           <a:p xmlns:a="http://schemas.openxmlformats.org/drawingml/2006/main">
             <a:pPr algn="l">
+              <a:buNone/>
               <a:defRPr sz="1600">
                 <a:solidFill>
                   <a:srgbClr val="000000"/>
                 </a:solidFill>
-                <a:latin typeface="Helvetica Neue"/>
-                <a:ea typeface="Helvetica Neue"/>
-                <a:cs typeface="Helvetica Neue"/>
-              </a:defRPr>
-            </a:pPr>
-            <a:r>
+                <a:latin typeface="Noto Sans SC"/>
+                <a:ea typeface="Noto Sans SC"/>
+                <a:cs typeface="Noto Sans SC"/>
+              </a:defRPr>
+            </a:pPr>
+            <a:r>
+              <a:rPr sz="1600">
+                <a:solidFill>
+                  <a:srgbClr val="000000"/>
+                </a:solidFill>
+                <a:latin typeface="Noto Sans SC"/>
+                <a:ea typeface="Noto Sans SC"/>
+                <a:cs typeface="Noto Sans SC"/>
+              </a:rPr>
               <a:t>
 撤销凭证、停止任务、补偿副作用、事件复盘</a:t>
             </a:r>
@@ -3906,16 +4167,25 @@
           <a:lstStyle xmlns:a="http://schemas.openxmlformats.org/drawingml/2006/main"/>
           <a:p xmlns:a="http://schemas.openxmlformats.org/drawingml/2006/main">
             <a:pPr algn="l">
+              <a:buNone/>
               <a:defRPr sz="2400">
                 <a:solidFill>
                   <a:srgbClr val="000000"/>
                 </a:solidFill>
-                <a:latin typeface="Helvetica Neue"/>
-                <a:ea typeface="Helvetica Neue"/>
-                <a:cs typeface="Helvetica Neue"/>
-              </a:defRPr>
-            </a:pPr>
-            <a:r>
+                <a:latin typeface="Noto Sans SC"/>
+                <a:ea typeface="Noto Sans SC"/>
+                <a:cs typeface="Noto Sans SC"/>
+              </a:defRPr>
+            </a:pPr>
+            <a:r>
+              <a:rPr sz="2400">
+                <a:solidFill>
+                  <a:srgbClr val="000000"/>
+                </a:solidFill>
+                <a:latin typeface="Noto Sans SC"/>
+                <a:ea typeface="Noto Sans SC"/>
+                <a:cs typeface="Noto Sans SC"/>
+              </a:rPr>
               <a:t>检测</a:t>
             </a:r>
           </a:p>
@@ -3951,16 +4221,25 @@
           <a:lstStyle xmlns:a="http://schemas.openxmlformats.org/drawingml/2006/main"/>
           <a:p xmlns:a="http://schemas.openxmlformats.org/drawingml/2006/main">
             <a:pPr algn="l">
+              <a:buNone/>
               <a:defRPr sz="2400">
                 <a:solidFill>
                   <a:srgbClr val="000000"/>
                 </a:solidFill>
-                <a:latin typeface="Helvetica Neue"/>
-                <a:ea typeface="Helvetica Neue"/>
-                <a:cs typeface="Helvetica Neue"/>
-              </a:defRPr>
-            </a:pPr>
-            <a:r>
+                <a:latin typeface="Noto Sans SC"/>
+                <a:ea typeface="Noto Sans SC"/>
+                <a:cs typeface="Noto Sans SC"/>
+              </a:defRPr>
+            </a:pPr>
+            <a:r>
+              <a:rPr sz="2400">
+                <a:solidFill>
+                  <a:srgbClr val="000000"/>
+                </a:solidFill>
+                <a:latin typeface="Noto Sans SC"/>
+                <a:ea typeface="Noto Sans SC"/>
+                <a:cs typeface="Noto Sans SC"/>
+              </a:rPr>
               <a:t>预防</a:t>
             </a:r>
           </a:p>
@@ -3996,16 +4275,25 @@
           <a:lstStyle xmlns:a="http://schemas.openxmlformats.org/drawingml/2006/main"/>
           <a:p xmlns:a="http://schemas.openxmlformats.org/drawingml/2006/main">
             <a:pPr algn="l">
+              <a:buNone/>
               <a:defRPr sz="2400">
                 <a:solidFill>
                   <a:srgbClr val="000000"/>
                 </a:solidFill>
-                <a:latin typeface="Helvetica Neue"/>
-                <a:ea typeface="Helvetica Neue"/>
-                <a:cs typeface="Helvetica Neue"/>
-              </a:defRPr>
-            </a:pPr>
-            <a:r>
+                <a:latin typeface="Noto Sans SC"/>
+                <a:ea typeface="Noto Sans SC"/>
+                <a:cs typeface="Noto Sans SC"/>
+              </a:defRPr>
+            </a:pPr>
+            <a:r>
+              <a:rPr sz="2400">
+                <a:solidFill>
+                  <a:srgbClr val="000000"/>
+                </a:solidFill>
+                <a:latin typeface="Noto Sans SC"/>
+                <a:ea typeface="Noto Sans SC"/>
+                <a:cs typeface="Noto Sans SC"/>
+              </a:rPr>
               <a:t>恢复</a:t>
             </a:r>
           </a:p>
@@ -4061,16 +4349,25 @@
           <a:lstStyle xmlns:a="http://schemas.openxmlformats.org/drawingml/2006/main"/>
           <a:p xmlns:a="http://schemas.openxmlformats.org/drawingml/2006/main">
             <a:pPr algn="r">
+              <a:buNone/>
               <a:defRPr sz="1000">
                 <a:solidFill>
                   <a:srgbClr val="000000"/>
                 </a:solidFill>
-                <a:latin typeface="Helvetica Neue"/>
-                <a:ea typeface="Helvetica Neue"/>
-                <a:cs typeface="Helvetica Neue"/>
-              </a:defRPr>
-            </a:pPr>
-            <a:r>
+                <a:latin typeface="Noto Sans SC"/>
+                <a:ea typeface="Noto Sans SC"/>
+                <a:cs typeface="Noto Sans SC"/>
+              </a:defRPr>
+            </a:pPr>
+            <a:r>
+              <a:rPr sz="1000">
+                <a:solidFill>
+                  <a:srgbClr val="000000"/>
+                </a:solidFill>
+                <a:latin typeface="Noto Sans SC"/>
+                <a:ea typeface="Noto Sans SC"/>
+                <a:cs typeface="Noto Sans SC"/>
+              </a:rPr>
               <a:t>13</a:t>
             </a:r>
           </a:p>
@@ -4106,16 +4403,25 @@
           <a:lstStyle xmlns:a="http://schemas.openxmlformats.org/drawingml/2006/main"/>
           <a:p xmlns:a="http://schemas.openxmlformats.org/drawingml/2006/main">
             <a:pPr algn="l">
+              <a:buNone/>
               <a:defRPr sz="2900">
                 <a:solidFill>
                   <a:srgbClr val="000000"/>
                 </a:solidFill>
-                <a:latin typeface="Helvetica Neue"/>
-                <a:ea typeface="Helvetica Neue"/>
-                <a:cs typeface="Helvetica Neue"/>
-              </a:defRPr>
-            </a:pPr>
-            <a:r>
+                <a:latin typeface="Noto Sans SC"/>
+                <a:ea typeface="Noto Sans SC"/>
+                <a:cs typeface="Noto Sans SC"/>
+              </a:defRPr>
+            </a:pPr>
+            <a:r>
+              <a:rPr sz="2900">
+                <a:solidFill>
+                  <a:srgbClr val="000000"/>
+                </a:solidFill>
+                <a:latin typeface="Noto Sans SC"/>
+                <a:ea typeface="Noto Sans SC"/>
+                <a:cs typeface="Noto Sans SC"/>
+              </a:rPr>
               <a:t>Evaluation 要覆盖任务、工具、检索与事实</a:t>
             </a:r>
           </a:p>
@@ -4149,31 +4455,49 @@
           <a:lstStyle xmlns:a="http://schemas.openxmlformats.org/drawingml/2006/main"/>
           <a:p xmlns:a="http://schemas.openxmlformats.org/drawingml/2006/main">
             <a:pPr algn="l">
+              <a:buNone/>
               <a:defRPr sz="2400">
                 <a:solidFill>
                   <a:srgbClr val="000000"/>
                 </a:solidFill>
-                <a:latin typeface="Helvetica Neue"/>
-                <a:ea typeface="Helvetica Neue"/>
-                <a:cs typeface="Helvetica Neue"/>
-              </a:defRPr>
-            </a:pPr>
-            <a:r>
+                <a:latin typeface="Noto Sans SC"/>
+                <a:ea typeface="Noto Sans SC"/>
+                <a:cs typeface="Noto Sans SC"/>
+              </a:defRPr>
+            </a:pPr>
+            <a:r>
+              <a:rPr sz="2400">
+                <a:solidFill>
+                  <a:srgbClr val="000000"/>
+                </a:solidFill>
+                <a:latin typeface="Noto Sans SC"/>
+                <a:ea typeface="Noto Sans SC"/>
+                <a:cs typeface="Noto Sans SC"/>
+              </a:rPr>
               <a:t>任务</a:t>
             </a:r>
           </a:p>
           <a:p xmlns:a="http://schemas.openxmlformats.org/drawingml/2006/main">
             <a:pPr algn="l">
+              <a:buNone/>
               <a:defRPr sz="2400">
                 <a:solidFill>
                   <a:srgbClr val="000000"/>
                 </a:solidFill>
-                <a:latin typeface="Helvetica Neue"/>
-                <a:ea typeface="Helvetica Neue"/>
-                <a:cs typeface="Helvetica Neue"/>
-              </a:defRPr>
-            </a:pPr>
-            <a:r>
+                <a:latin typeface="Noto Sans SC"/>
+                <a:ea typeface="Noto Sans SC"/>
+                <a:cs typeface="Noto Sans SC"/>
+              </a:defRPr>
+            </a:pPr>
+            <a:r>
+              <a:rPr sz="2400">
+                <a:solidFill>
+                  <a:srgbClr val="000000"/>
+                </a:solidFill>
+                <a:latin typeface="Noto Sans SC"/>
+                <a:ea typeface="Noto Sans SC"/>
+                <a:cs typeface="Noto Sans SC"/>
+              </a:rPr>
               <a:t>
 Task Success 与业务验收</a:t>
             </a:r>
@@ -4208,31 +4532,49 @@
           <a:lstStyle xmlns:a="http://schemas.openxmlformats.org/drawingml/2006/main"/>
           <a:p xmlns:a="http://schemas.openxmlformats.org/drawingml/2006/main">
             <a:pPr algn="l">
+              <a:buNone/>
               <a:defRPr sz="2400">
                 <a:solidFill>
                   <a:srgbClr val="000000"/>
                 </a:solidFill>
-                <a:latin typeface="Helvetica Neue"/>
-                <a:ea typeface="Helvetica Neue"/>
-                <a:cs typeface="Helvetica Neue"/>
-              </a:defRPr>
-            </a:pPr>
-            <a:r>
+                <a:latin typeface="Noto Sans SC"/>
+                <a:ea typeface="Noto Sans SC"/>
+                <a:cs typeface="Noto Sans SC"/>
+              </a:defRPr>
+            </a:pPr>
+            <a:r>
+              <a:rPr sz="2400">
+                <a:solidFill>
+                  <a:srgbClr val="000000"/>
+                </a:solidFill>
+                <a:latin typeface="Noto Sans SC"/>
+                <a:ea typeface="Noto Sans SC"/>
+                <a:cs typeface="Noto Sans SC"/>
+              </a:rPr>
               <a:t>工具</a:t>
             </a:r>
           </a:p>
           <a:p xmlns:a="http://schemas.openxmlformats.org/drawingml/2006/main">
             <a:pPr algn="l">
+              <a:buNone/>
               <a:defRPr sz="2400">
                 <a:solidFill>
                   <a:srgbClr val="000000"/>
                 </a:solidFill>
-                <a:latin typeface="Helvetica Neue"/>
-                <a:ea typeface="Helvetica Neue"/>
-                <a:cs typeface="Helvetica Neue"/>
-              </a:defRPr>
-            </a:pPr>
-            <a:r>
+                <a:latin typeface="Noto Sans SC"/>
+                <a:ea typeface="Noto Sans SC"/>
+                <a:cs typeface="Noto Sans SC"/>
+              </a:defRPr>
+            </a:pPr>
+            <a:r>
+              <a:rPr sz="2400">
+                <a:solidFill>
+                  <a:srgbClr val="000000"/>
+                </a:solidFill>
+                <a:latin typeface="Noto Sans SC"/>
+                <a:ea typeface="Noto Sans SC"/>
+                <a:cs typeface="Noto Sans SC"/>
+              </a:rPr>
               <a:t>
 选择、参数、权限与副作用</a:t>
             </a:r>
@@ -4269,31 +4611,49 @@
           <a:lstStyle xmlns:a="http://schemas.openxmlformats.org/drawingml/2006/main"/>
           <a:p xmlns:a="http://schemas.openxmlformats.org/drawingml/2006/main">
             <a:pPr algn="l">
+              <a:buNone/>
               <a:defRPr sz="2400">
                 <a:solidFill>
                   <a:srgbClr val="000000"/>
                 </a:solidFill>
-                <a:latin typeface="Helvetica Neue"/>
-                <a:ea typeface="Helvetica Neue"/>
-                <a:cs typeface="Helvetica Neue"/>
-              </a:defRPr>
-            </a:pPr>
-            <a:r>
+                <a:latin typeface="Noto Sans SC"/>
+                <a:ea typeface="Noto Sans SC"/>
+                <a:cs typeface="Noto Sans SC"/>
+              </a:defRPr>
+            </a:pPr>
+            <a:r>
+              <a:rPr sz="2400">
+                <a:solidFill>
+                  <a:srgbClr val="000000"/>
+                </a:solidFill>
+                <a:latin typeface="Noto Sans SC"/>
+                <a:ea typeface="Noto Sans SC"/>
+                <a:cs typeface="Noto Sans SC"/>
+              </a:rPr>
               <a:t>检索</a:t>
             </a:r>
           </a:p>
           <a:p xmlns:a="http://schemas.openxmlformats.org/drawingml/2006/main">
             <a:pPr algn="l">
+              <a:buNone/>
               <a:defRPr sz="2400">
                 <a:solidFill>
                   <a:srgbClr val="000000"/>
                 </a:solidFill>
-                <a:latin typeface="Helvetica Neue"/>
-                <a:ea typeface="Helvetica Neue"/>
-                <a:cs typeface="Helvetica Neue"/>
-              </a:defRPr>
-            </a:pPr>
-            <a:r>
+                <a:latin typeface="Noto Sans SC"/>
+                <a:ea typeface="Noto Sans SC"/>
+                <a:cs typeface="Noto Sans SC"/>
+              </a:defRPr>
+            </a:pPr>
+            <a:r>
+              <a:rPr sz="2400">
+                <a:solidFill>
+                  <a:srgbClr val="000000"/>
+                </a:solidFill>
+                <a:latin typeface="Noto Sans SC"/>
+                <a:ea typeface="Noto Sans SC"/>
+                <a:cs typeface="Noto Sans SC"/>
+              </a:rPr>
               <a:t>
 Recall、MRR、过滤与引用</a:t>
             </a:r>
@@ -4330,31 +4690,49 @@
           <a:lstStyle xmlns:a="http://schemas.openxmlformats.org/drawingml/2006/main"/>
           <a:p xmlns:a="http://schemas.openxmlformats.org/drawingml/2006/main">
             <a:pPr algn="l">
+              <a:buNone/>
               <a:defRPr sz="2400">
                 <a:solidFill>
                   <a:srgbClr val="000000"/>
                 </a:solidFill>
-                <a:latin typeface="Helvetica Neue"/>
-                <a:ea typeface="Helvetica Neue"/>
-                <a:cs typeface="Helvetica Neue"/>
-              </a:defRPr>
-            </a:pPr>
-            <a:r>
+                <a:latin typeface="Noto Sans SC"/>
+                <a:ea typeface="Noto Sans SC"/>
+                <a:cs typeface="Noto Sans SC"/>
+              </a:defRPr>
+            </a:pPr>
+            <a:r>
+              <a:rPr sz="2400">
+                <a:solidFill>
+                  <a:srgbClr val="000000"/>
+                </a:solidFill>
+                <a:latin typeface="Noto Sans SC"/>
+                <a:ea typeface="Noto Sans SC"/>
+                <a:cs typeface="Noto Sans SC"/>
+              </a:rPr>
               <a:t>生成</a:t>
             </a:r>
           </a:p>
           <a:p xmlns:a="http://schemas.openxmlformats.org/drawingml/2006/main">
             <a:pPr algn="l">
+              <a:buNone/>
               <a:defRPr sz="2400">
                 <a:solidFill>
                   <a:srgbClr val="000000"/>
                 </a:solidFill>
-                <a:latin typeface="Helvetica Neue"/>
-                <a:ea typeface="Helvetica Neue"/>
-                <a:cs typeface="Helvetica Neue"/>
-              </a:defRPr>
-            </a:pPr>
-            <a:r>
+                <a:latin typeface="Noto Sans SC"/>
+                <a:ea typeface="Noto Sans SC"/>
+                <a:cs typeface="Noto Sans SC"/>
+              </a:defRPr>
+            </a:pPr>
+            <a:r>
+              <a:rPr sz="2400">
+                <a:solidFill>
+                  <a:srgbClr val="000000"/>
+                </a:solidFill>
+                <a:latin typeface="Noto Sans SC"/>
+                <a:ea typeface="Noto Sans SC"/>
+                <a:cs typeface="Noto Sans SC"/>
+              </a:rPr>
               <a:t>
 Faithfulness、拒答与人工复核</a:t>
             </a:r>
@@ -4411,16 +4789,25 @@
           <a:lstStyle xmlns:a="http://schemas.openxmlformats.org/drawingml/2006/main"/>
           <a:p xmlns:a="http://schemas.openxmlformats.org/drawingml/2006/main">
             <a:pPr algn="l">
+              <a:buNone/>
               <a:defRPr sz="1000">
                 <a:solidFill>
                   <a:srgbClr val="000000"/>
                 </a:solidFill>
-                <a:latin typeface="Helvetica Neue"/>
-                <a:ea typeface="Helvetica Neue"/>
-                <a:cs typeface="Helvetica Neue"/>
-              </a:defRPr>
-            </a:pPr>
-            <a:r>
+                <a:latin typeface="Noto Sans SC"/>
+                <a:ea typeface="Noto Sans SC"/>
+                <a:cs typeface="Noto Sans SC"/>
+              </a:defRPr>
+            </a:pPr>
+            <a:r>
+              <a:rPr sz="1000">
+                <a:solidFill>
+                  <a:srgbClr val="000000"/>
+                </a:solidFill>
+                <a:latin typeface="Noto Sans SC"/>
+                <a:ea typeface="Noto Sans SC"/>
+                <a:cs typeface="Noto Sans SC"/>
+              </a:rPr>
               <a:t>14</a:t>
             </a:r>
           </a:p>
@@ -4456,16 +4843,25 @@
           <a:lstStyle xmlns:a="http://schemas.openxmlformats.org/drawingml/2006/main"/>
           <a:p xmlns:a="http://schemas.openxmlformats.org/drawingml/2006/main">
             <a:pPr algn="l">
+              <a:buNone/>
               <a:defRPr sz="2900">
                 <a:solidFill>
                   <a:srgbClr val="000000"/>
                 </a:solidFill>
-                <a:latin typeface="Helvetica Neue"/>
-                <a:ea typeface="Helvetica Neue"/>
-                <a:cs typeface="Helvetica Neue"/>
-              </a:defRPr>
-            </a:pPr>
-            <a:r>
+                <a:latin typeface="Noto Sans SC"/>
+                <a:ea typeface="Noto Sans SC"/>
+                <a:cs typeface="Noto Sans SC"/>
+              </a:defRPr>
+            </a:pPr>
+            <a:r>
+              <a:rPr sz="2900">
+                <a:solidFill>
+                  <a:srgbClr val="000000"/>
+                </a:solidFill>
+                <a:latin typeface="Noto Sans SC"/>
+                <a:ea typeface="Noto Sans SC"/>
+                <a:cs typeface="Noto Sans SC"/>
+              </a:rPr>
               <a:t>三条学习路线共享同一验收逻辑</a:t>
             </a:r>
           </a:p>
@@ -4473,7 +4869,7 @@
       </p:sp>
       <p:cxnSp>
         <p:nvCxnSpPr>
-          <p:cNvPr id="15" name="Google-Shape-2259-p159-4"/>
+          <p:cNvPr id="21" name="Google-Shape-2259-p159-4"/>
           <p:cNvCxnSpPr/>
           <p:nvPr/>
         </p:nvCxnSpPr>
@@ -4604,16 +5000,25 @@
           <a:lstStyle xmlns:a="http://schemas.openxmlformats.org/drawingml/2006/main"/>
           <a:p xmlns:a="http://schemas.openxmlformats.org/drawingml/2006/main">
             <a:pPr algn="l">
+              <a:buNone/>
               <a:defRPr sz="1600">
                 <a:solidFill>
                   <a:srgbClr val="000000"/>
                 </a:solidFill>
-                <a:latin typeface="Helvetica Neue"/>
-                <a:ea typeface="Helvetica Neue"/>
-                <a:cs typeface="Helvetica Neue"/>
-              </a:defRPr>
-            </a:pPr>
-            <a:r>
+                <a:latin typeface="Noto Sans SC"/>
+                <a:ea typeface="Noto Sans SC"/>
+                <a:cs typeface="Noto Sans SC"/>
+              </a:defRPr>
+            </a:pPr>
+            <a:r>
+              <a:rPr sz="1600">
+                <a:solidFill>
+                  <a:srgbClr val="000000"/>
+                </a:solidFill>
+                <a:latin typeface="Noto Sans SC"/>
+                <a:ea typeface="Noto Sans SC"/>
+                <a:cs typeface="Noto Sans SC"/>
+              </a:rPr>
               <a:t>8 周</a:t>
             </a:r>
           </a:p>
@@ -4649,16 +5054,25 @@
           <a:lstStyle xmlns:a="http://schemas.openxmlformats.org/drawingml/2006/main"/>
           <a:p xmlns:a="http://schemas.openxmlformats.org/drawingml/2006/main">
             <a:pPr algn="l">
+              <a:buNone/>
               <a:defRPr sz="1600">
                 <a:solidFill>
                   <a:srgbClr val="000000"/>
                 </a:solidFill>
-                <a:latin typeface="Helvetica Neue"/>
-                <a:ea typeface="Helvetica Neue"/>
-                <a:cs typeface="Helvetica Neue"/>
-              </a:defRPr>
-            </a:pPr>
-            <a:r>
+                <a:latin typeface="Noto Sans SC"/>
+                <a:ea typeface="Noto Sans SC"/>
+                <a:cs typeface="Noto Sans SC"/>
+              </a:defRPr>
+            </a:pPr>
+            <a:r>
+              <a:rPr sz="1600">
+                <a:solidFill>
+                  <a:srgbClr val="000000"/>
+                </a:solidFill>
+                <a:latin typeface="Noto Sans SC"/>
+                <a:ea typeface="Noto Sans SC"/>
+                <a:cs typeface="Noto Sans SC"/>
+              </a:rPr>
               <a:t>12 周</a:t>
             </a:r>
           </a:p>
@@ -4694,16 +5108,25 @@
           <a:lstStyle xmlns:a="http://schemas.openxmlformats.org/drawingml/2006/main"/>
           <a:p xmlns:a="http://schemas.openxmlformats.org/drawingml/2006/main">
             <a:pPr algn="l">
+              <a:buNone/>
               <a:defRPr sz="1600">
                 <a:solidFill>
                   <a:srgbClr val="000000"/>
                 </a:solidFill>
-                <a:latin typeface="Helvetica Neue"/>
-                <a:ea typeface="Helvetica Neue"/>
-                <a:cs typeface="Helvetica Neue"/>
-              </a:defRPr>
-            </a:pPr>
-            <a:r>
+                <a:latin typeface="Noto Sans SC"/>
+                <a:ea typeface="Noto Sans SC"/>
+                <a:cs typeface="Noto Sans SC"/>
+              </a:defRPr>
+            </a:pPr>
+            <a:r>
+              <a:rPr sz="1600">
+                <a:solidFill>
+                  <a:srgbClr val="000000"/>
+                </a:solidFill>
+                <a:latin typeface="Noto Sans SC"/>
+                <a:ea typeface="Noto Sans SC"/>
+                <a:cs typeface="Noto Sans SC"/>
+              </a:rPr>
               <a:t>24 周</a:t>
             </a:r>
           </a:p>
@@ -4739,31 +5162,49 @@
           <a:lstStyle xmlns:a="http://schemas.openxmlformats.org/drawingml/2006/main"/>
           <a:p xmlns:a="http://schemas.openxmlformats.org/drawingml/2006/main">
             <a:pPr algn="l">
+              <a:buNone/>
               <a:defRPr sz="2400">
                 <a:solidFill>
                   <a:srgbClr val="000000"/>
                 </a:solidFill>
-                <a:latin typeface="Helvetica Neue"/>
-                <a:ea typeface="Helvetica Neue"/>
-                <a:cs typeface="Helvetica Neue"/>
-              </a:defRPr>
-            </a:pPr>
-            <a:r>
+                <a:latin typeface="Noto Sans SC"/>
+                <a:ea typeface="Noto Sans SC"/>
+                <a:cs typeface="Noto Sans SC"/>
+              </a:defRPr>
+            </a:pPr>
+            <a:r>
+              <a:rPr sz="2400">
+                <a:solidFill>
+                  <a:srgbClr val="000000"/>
+                </a:solidFill>
+                <a:latin typeface="Noto Sans SC"/>
+                <a:ea typeface="Noto Sans SC"/>
+                <a:cs typeface="Noto Sans SC"/>
+              </a:rPr>
               <a:t>系统学习</a:t>
             </a:r>
           </a:p>
           <a:p xmlns:a="http://schemas.openxmlformats.org/drawingml/2006/main">
             <a:pPr algn="l">
+              <a:buNone/>
               <a:defRPr sz="2400">
                 <a:solidFill>
                   <a:srgbClr val="000000"/>
                 </a:solidFill>
-                <a:latin typeface="Helvetica Neue"/>
-                <a:ea typeface="Helvetica Neue"/>
-                <a:cs typeface="Helvetica Neue"/>
-              </a:defRPr>
-            </a:pPr>
-            <a:r>
+                <a:latin typeface="Noto Sans SC"/>
+                <a:ea typeface="Noto Sans SC"/>
+                <a:cs typeface="Noto Sans SC"/>
+              </a:defRPr>
+            </a:pPr>
+            <a:r>
+              <a:rPr sz="2400">
+                <a:solidFill>
+                  <a:srgbClr val="000000"/>
+                </a:solidFill>
+                <a:latin typeface="Noto Sans SC"/>
+                <a:ea typeface="Noto Sans SC"/>
+                <a:cs typeface="Noto Sans SC"/>
+              </a:rPr>
               <a:t>
 完成 RAG 工作流</a:t>
             </a:r>
@@ -4800,31 +5241,49 @@
           <a:lstStyle xmlns:a="http://schemas.openxmlformats.org/drawingml/2006/main"/>
           <a:p xmlns:a="http://schemas.openxmlformats.org/drawingml/2006/main">
             <a:pPr algn="l">
+              <a:buNone/>
               <a:defRPr sz="2400">
                 <a:solidFill>
                   <a:srgbClr val="000000"/>
                 </a:solidFill>
-                <a:latin typeface="Helvetica Neue"/>
-                <a:ea typeface="Helvetica Neue"/>
-                <a:cs typeface="Helvetica Neue"/>
-              </a:defRPr>
-            </a:pPr>
-            <a:r>
+                <a:latin typeface="Noto Sans SC"/>
+                <a:ea typeface="Noto Sans SC"/>
+                <a:cs typeface="Noto Sans SC"/>
+              </a:defRPr>
+            </a:pPr>
+            <a:r>
+              <a:rPr sz="2400">
+                <a:solidFill>
+                  <a:srgbClr val="000000"/>
+                </a:solidFill>
+                <a:latin typeface="Noto Sans SC"/>
+                <a:ea typeface="Noto Sans SC"/>
+                <a:cs typeface="Noto Sans SC"/>
+              </a:rPr>
               <a:t>快速入门</a:t>
             </a:r>
           </a:p>
           <a:p xmlns:a="http://schemas.openxmlformats.org/drawingml/2006/main">
             <a:pPr algn="l">
+              <a:buNone/>
               <a:defRPr sz="2400">
                 <a:solidFill>
                   <a:srgbClr val="000000"/>
                 </a:solidFill>
-                <a:latin typeface="Helvetica Neue"/>
-                <a:ea typeface="Helvetica Neue"/>
-                <a:cs typeface="Helvetica Neue"/>
-              </a:defRPr>
-            </a:pPr>
-            <a:r>
+                <a:latin typeface="Noto Sans SC"/>
+                <a:ea typeface="Noto Sans SC"/>
+                <a:cs typeface="Noto Sans SC"/>
+              </a:defRPr>
+            </a:pPr>
+            <a:r>
+              <a:rPr sz="2400">
+                <a:solidFill>
+                  <a:srgbClr val="000000"/>
+                </a:solidFill>
+                <a:latin typeface="Noto Sans SC"/>
+                <a:ea typeface="Noto Sans SC"/>
+                <a:cs typeface="Noto Sans SC"/>
+              </a:rPr>
               <a:t>
 完成两个项目</a:t>
             </a:r>
@@ -4861,31 +5320,49 @@
           <a:lstStyle xmlns:a="http://schemas.openxmlformats.org/drawingml/2006/main"/>
           <a:p xmlns:a="http://schemas.openxmlformats.org/drawingml/2006/main">
             <a:pPr algn="l">
+              <a:buNone/>
               <a:defRPr sz="2400">
                 <a:solidFill>
                   <a:srgbClr val="000000"/>
                 </a:solidFill>
-                <a:latin typeface="Helvetica Neue"/>
-                <a:ea typeface="Helvetica Neue"/>
-                <a:cs typeface="Helvetica Neue"/>
-              </a:defRPr>
-            </a:pPr>
-            <a:r>
+                <a:latin typeface="Noto Sans SC"/>
+                <a:ea typeface="Noto Sans SC"/>
+                <a:cs typeface="Noto Sans SC"/>
+              </a:defRPr>
+            </a:pPr>
+            <a:r>
+              <a:rPr sz="2400">
+                <a:solidFill>
+                  <a:srgbClr val="000000"/>
+                </a:solidFill>
+                <a:latin typeface="Noto Sans SC"/>
+                <a:ea typeface="Noto Sans SC"/>
+                <a:cs typeface="Noto Sans SC"/>
+              </a:rPr>
               <a:t>深入进阶</a:t>
             </a:r>
           </a:p>
           <a:p xmlns:a="http://schemas.openxmlformats.org/drawingml/2006/main">
             <a:pPr algn="l">
+              <a:buNone/>
               <a:defRPr sz="2400">
                 <a:solidFill>
                   <a:srgbClr val="000000"/>
                 </a:solidFill>
-                <a:latin typeface="Helvetica Neue"/>
-                <a:ea typeface="Helvetica Neue"/>
-                <a:cs typeface="Helvetica Neue"/>
-              </a:defRPr>
-            </a:pPr>
-            <a:r>
+                <a:latin typeface="Noto Sans SC"/>
+                <a:ea typeface="Noto Sans SC"/>
+                <a:cs typeface="Noto Sans SC"/>
+              </a:defRPr>
+            </a:pPr>
+            <a:r>
+              <a:rPr sz="2400">
+                <a:solidFill>
+                  <a:srgbClr val="000000"/>
+                </a:solidFill>
+                <a:latin typeface="Noto Sans SC"/>
+                <a:ea typeface="Noto Sans SC"/>
+                <a:cs typeface="Noto Sans SC"/>
+              </a:rPr>
               <a:t>
 完成生产参考项目</a:t>
             </a:r>
@@ -4942,16 +5419,25 @@
           <a:lstStyle xmlns:a="http://schemas.openxmlformats.org/drawingml/2006/main"/>
           <a:p xmlns:a="http://schemas.openxmlformats.org/drawingml/2006/main">
             <a:pPr algn="r">
+              <a:buNone/>
               <a:defRPr sz="1000">
                 <a:solidFill>
                   <a:srgbClr val="000000"/>
                 </a:solidFill>
-                <a:latin typeface="Helvetica Neue"/>
-                <a:ea typeface="Helvetica Neue"/>
-                <a:cs typeface="Helvetica Neue"/>
-              </a:defRPr>
-            </a:pPr>
-            <a:r>
+                <a:latin typeface="Noto Sans SC"/>
+                <a:ea typeface="Noto Sans SC"/>
+                <a:cs typeface="Noto Sans SC"/>
+              </a:defRPr>
+            </a:pPr>
+            <a:r>
+              <a:rPr sz="1000">
+                <a:solidFill>
+                  <a:srgbClr val="000000"/>
+                </a:solidFill>
+                <a:latin typeface="Noto Sans SC"/>
+                <a:ea typeface="Noto Sans SC"/>
+                <a:cs typeface="Noto Sans SC"/>
+              </a:rPr>
               <a:t>15</a:t>
             </a:r>
           </a:p>
@@ -4987,16 +5473,25 @@
           <a:lstStyle xmlns:a="http://schemas.openxmlformats.org/drawingml/2006/main"/>
           <a:p xmlns:a="http://schemas.openxmlformats.org/drawingml/2006/main">
             <a:pPr algn="l">
+              <a:buNone/>
               <a:defRPr sz="2900">
                 <a:solidFill>
                   <a:srgbClr val="000000"/>
                 </a:solidFill>
-                <a:latin typeface="Helvetica Neue"/>
-                <a:ea typeface="Helvetica Neue"/>
-                <a:cs typeface="Helvetica Neue"/>
-              </a:defRPr>
-            </a:pPr>
-            <a:r>
+                <a:latin typeface="Noto Sans SC"/>
+                <a:ea typeface="Noto Sans SC"/>
+                <a:cs typeface="Noto Sans SC"/>
+              </a:defRPr>
+            </a:pPr>
+            <a:r>
+              <a:rPr sz="2900">
+                <a:solidFill>
+                  <a:srgbClr val="000000"/>
+                </a:solidFill>
+                <a:latin typeface="Noto Sans SC"/>
+                <a:ea typeface="Noto Sans SC"/>
+                <a:cs typeface="Noto Sans SC"/>
+              </a:rPr>
               <a:t>实验提交必须形成可复核证据</a:t>
             </a:r>
           </a:p>
@@ -5030,31 +5525,49 @@
           <a:lstStyle xmlns:a="http://schemas.openxmlformats.org/drawingml/2006/main"/>
           <a:p xmlns:a="http://schemas.openxmlformats.org/drawingml/2006/main">
             <a:pPr algn="l">
+              <a:buNone/>
               <a:defRPr sz="2400">
                 <a:solidFill>
                   <a:srgbClr val="000000"/>
                 </a:solidFill>
-                <a:latin typeface="Helvetica Neue"/>
-                <a:ea typeface="Helvetica Neue"/>
-                <a:cs typeface="Helvetica Neue"/>
-              </a:defRPr>
-            </a:pPr>
-            <a:r>
+                <a:latin typeface="Noto Sans SC"/>
+                <a:ea typeface="Noto Sans SC"/>
+                <a:cs typeface="Noto Sans SC"/>
+              </a:defRPr>
+            </a:pPr>
+            <a:r>
+              <a:rPr sz="2400">
+                <a:solidFill>
+                  <a:srgbClr val="000000"/>
+                </a:solidFill>
+                <a:latin typeface="Noto Sans SC"/>
+                <a:ea typeface="Noto Sans SC"/>
+                <a:cs typeface="Noto Sans SC"/>
+              </a:rPr>
               <a:t>可运行</a:t>
             </a:r>
           </a:p>
           <a:p xmlns:a="http://schemas.openxmlformats.org/drawingml/2006/main">
             <a:pPr algn="l">
+              <a:buNone/>
               <a:defRPr sz="2400">
                 <a:solidFill>
                   <a:srgbClr val="000000"/>
                 </a:solidFill>
-                <a:latin typeface="Helvetica Neue"/>
-                <a:ea typeface="Helvetica Neue"/>
-                <a:cs typeface="Helvetica Neue"/>
-              </a:defRPr>
-            </a:pPr>
-            <a:r>
+                <a:latin typeface="Noto Sans SC"/>
+                <a:ea typeface="Noto Sans SC"/>
+                <a:cs typeface="Noto Sans SC"/>
+              </a:defRPr>
+            </a:pPr>
+            <a:r>
+              <a:rPr sz="2400">
+                <a:solidFill>
+                  <a:srgbClr val="000000"/>
+                </a:solidFill>
+                <a:latin typeface="Noto Sans SC"/>
+                <a:ea typeface="Noto Sans SC"/>
+                <a:cs typeface="Noto Sans SC"/>
+              </a:rPr>
               <a:t>
 源码、配置与固定环境</a:t>
             </a:r>
@@ -5089,31 +5602,49 @@
           <a:lstStyle xmlns:a="http://schemas.openxmlformats.org/drawingml/2006/main"/>
           <a:p xmlns:a="http://schemas.openxmlformats.org/drawingml/2006/main">
             <a:pPr algn="l">
+              <a:buNone/>
               <a:defRPr sz="2400">
                 <a:solidFill>
                   <a:srgbClr val="000000"/>
                 </a:solidFill>
-                <a:latin typeface="Helvetica Neue"/>
-                <a:ea typeface="Helvetica Neue"/>
-                <a:cs typeface="Helvetica Neue"/>
-              </a:defRPr>
-            </a:pPr>
-            <a:r>
+                <a:latin typeface="Noto Sans SC"/>
+                <a:ea typeface="Noto Sans SC"/>
+                <a:cs typeface="Noto Sans SC"/>
+              </a:defRPr>
+            </a:pPr>
+            <a:r>
+              <a:rPr sz="2400">
+                <a:solidFill>
+                  <a:srgbClr val="000000"/>
+                </a:solidFill>
+                <a:latin typeface="Noto Sans SC"/>
+                <a:ea typeface="Noto Sans SC"/>
+                <a:cs typeface="Noto Sans SC"/>
+              </a:rPr>
               <a:t>可测试</a:t>
             </a:r>
           </a:p>
           <a:p xmlns:a="http://schemas.openxmlformats.org/drawingml/2006/main">
             <a:pPr algn="l">
+              <a:buNone/>
               <a:defRPr sz="2400">
                 <a:solidFill>
                   <a:srgbClr val="000000"/>
                 </a:solidFill>
-                <a:latin typeface="Helvetica Neue"/>
-                <a:ea typeface="Helvetica Neue"/>
-                <a:cs typeface="Helvetica Neue"/>
-              </a:defRPr>
-            </a:pPr>
-            <a:r>
+                <a:latin typeface="Noto Sans SC"/>
+                <a:ea typeface="Noto Sans SC"/>
+                <a:cs typeface="Noto Sans SC"/>
+              </a:defRPr>
+            </a:pPr>
+            <a:r>
+              <a:rPr sz="2400">
+                <a:solidFill>
+                  <a:srgbClr val="000000"/>
+                </a:solidFill>
+                <a:latin typeface="Noto Sans SC"/>
+                <a:ea typeface="Noto Sans SC"/>
+                <a:cs typeface="Noto Sans SC"/>
+              </a:rPr>
               <a:t>
 成功、失败和边界用例</a:t>
             </a:r>
@@ -5150,31 +5681,49 @@
           <a:lstStyle xmlns:a="http://schemas.openxmlformats.org/drawingml/2006/main"/>
           <a:p xmlns:a="http://schemas.openxmlformats.org/drawingml/2006/main">
             <a:pPr algn="l">
+              <a:buNone/>
               <a:defRPr sz="2400">
                 <a:solidFill>
                   <a:srgbClr val="000000"/>
                 </a:solidFill>
-                <a:latin typeface="Helvetica Neue"/>
-                <a:ea typeface="Helvetica Neue"/>
-                <a:cs typeface="Helvetica Neue"/>
-              </a:defRPr>
-            </a:pPr>
-            <a:r>
+                <a:latin typeface="Noto Sans SC"/>
+                <a:ea typeface="Noto Sans SC"/>
+                <a:cs typeface="Noto Sans SC"/>
+              </a:defRPr>
+            </a:pPr>
+            <a:r>
+              <a:rPr sz="2400">
+                <a:solidFill>
+                  <a:srgbClr val="000000"/>
+                </a:solidFill>
+                <a:latin typeface="Noto Sans SC"/>
+                <a:ea typeface="Noto Sans SC"/>
+                <a:cs typeface="Noto Sans SC"/>
+              </a:rPr>
               <a:t>可解释</a:t>
             </a:r>
           </a:p>
           <a:p xmlns:a="http://schemas.openxmlformats.org/drawingml/2006/main">
             <a:pPr algn="l">
+              <a:buNone/>
               <a:defRPr sz="2400">
                 <a:solidFill>
                   <a:srgbClr val="000000"/>
                 </a:solidFill>
-                <a:latin typeface="Helvetica Neue"/>
-                <a:ea typeface="Helvetica Neue"/>
-                <a:cs typeface="Helvetica Neue"/>
-              </a:defRPr>
-            </a:pPr>
-            <a:r>
+                <a:latin typeface="Noto Sans SC"/>
+                <a:ea typeface="Noto Sans SC"/>
+                <a:cs typeface="Noto Sans SC"/>
+              </a:defRPr>
+            </a:pPr>
+            <a:r>
+              <a:rPr sz="2400">
+                <a:solidFill>
+                  <a:srgbClr val="000000"/>
+                </a:solidFill>
+                <a:latin typeface="Noto Sans SC"/>
+                <a:ea typeface="Noto Sans SC"/>
+                <a:cs typeface="Noto Sans SC"/>
+              </a:rPr>
               <a:t>
 ADR、替代方案和未验证假设</a:t>
             </a:r>
@@ -5211,31 +5760,49 @@
           <a:lstStyle xmlns:a="http://schemas.openxmlformats.org/drawingml/2006/main"/>
           <a:p xmlns:a="http://schemas.openxmlformats.org/drawingml/2006/main">
             <a:pPr algn="l">
+              <a:buNone/>
               <a:defRPr sz="2400">
                 <a:solidFill>
                   <a:srgbClr val="000000"/>
                 </a:solidFill>
-                <a:latin typeface="Helvetica Neue"/>
-                <a:ea typeface="Helvetica Neue"/>
-                <a:cs typeface="Helvetica Neue"/>
-              </a:defRPr>
-            </a:pPr>
-            <a:r>
+                <a:latin typeface="Noto Sans SC"/>
+                <a:ea typeface="Noto Sans SC"/>
+                <a:cs typeface="Noto Sans SC"/>
+              </a:defRPr>
+            </a:pPr>
+            <a:r>
+              <a:rPr sz="2400">
+                <a:solidFill>
+                  <a:srgbClr val="000000"/>
+                </a:solidFill>
+                <a:latin typeface="Noto Sans SC"/>
+                <a:ea typeface="Noto Sans SC"/>
+                <a:cs typeface="Noto Sans SC"/>
+              </a:rPr>
               <a:t>可审计</a:t>
             </a:r>
           </a:p>
           <a:p xmlns:a="http://schemas.openxmlformats.org/drawingml/2006/main">
             <a:pPr algn="l">
+              <a:buNone/>
               <a:defRPr sz="2400">
                 <a:solidFill>
                   <a:srgbClr val="000000"/>
                 </a:solidFill>
-                <a:latin typeface="Helvetica Neue"/>
-                <a:ea typeface="Helvetica Neue"/>
-                <a:cs typeface="Helvetica Neue"/>
-              </a:defRPr>
-            </a:pPr>
-            <a:r>
+                <a:latin typeface="Noto Sans SC"/>
+                <a:ea typeface="Noto Sans SC"/>
+                <a:cs typeface="Noto Sans SC"/>
+              </a:defRPr>
+            </a:pPr>
+            <a:r>
+              <a:rPr sz="2400">
+                <a:solidFill>
+                  <a:srgbClr val="000000"/>
+                </a:solidFill>
+                <a:latin typeface="Noto Sans SC"/>
+                <a:ea typeface="Noto Sans SC"/>
+                <a:cs typeface="Noto Sans SC"/>
+              </a:rPr>
               <a:t>
 脱敏 Trace、指标和安全检查</a:t>
             </a:r>
@@ -5294,16 +5861,25 @@
           <a:lstStyle xmlns:a="http://schemas.openxmlformats.org/drawingml/2006/main"/>
           <a:p xmlns:a="http://schemas.openxmlformats.org/drawingml/2006/main">
             <a:pPr algn="l">
+              <a:buNone/>
               <a:defRPr sz="6000">
                 <a:solidFill>
                   <a:srgbClr val="000000"/>
                 </a:solidFill>
-                <a:latin typeface="Helvetica Neue"/>
-                <a:ea typeface="Helvetica Neue"/>
-                <a:cs typeface="Helvetica Neue"/>
-              </a:defRPr>
-            </a:pPr>
-            <a:r>
+                <a:latin typeface="Noto Sans SC"/>
+                <a:ea typeface="Noto Sans SC"/>
+                <a:cs typeface="Noto Sans SC"/>
+              </a:defRPr>
+            </a:pPr>
+            <a:r>
+              <a:rPr sz="6000">
+                <a:solidFill>
+                  <a:srgbClr val="000000"/>
+                </a:solidFill>
+                <a:latin typeface="Noto Sans SC"/>
+                <a:ea typeface="Noto Sans SC"/>
+                <a:cs typeface="Noto Sans SC"/>
+              </a:rPr>
               <a:t>用证据交付
 一个可靠 Agent</a:t>
             </a:r>
@@ -5340,48 +5916,75 @@
           <a:lstStyle xmlns:a="http://schemas.openxmlformats.org/drawingml/2006/main"/>
           <a:p xmlns:a="http://schemas.openxmlformats.org/drawingml/2006/main">
             <a:pPr algn="l">
+              <a:buNone/>
               <a:defRPr sz="2400">
                 <a:solidFill>
                   <a:srgbClr val="000000"/>
                 </a:solidFill>
-                <a:latin typeface="Helvetica Neue"/>
-                <a:ea typeface="Helvetica Neue"/>
-                <a:cs typeface="Helvetica Neue"/>
-              </a:defRPr>
-            </a:pPr>
-            <a:r>
+                <a:latin typeface="Noto Sans SC"/>
+                <a:ea typeface="Noto Sans SC"/>
+                <a:cs typeface="Noto Sans SC"/>
+              </a:defRPr>
+            </a:pPr>
+            <a:r>
+              <a:rPr sz="2400">
+                <a:solidFill>
+                  <a:srgbClr val="000000"/>
+                </a:solidFill>
+                <a:latin typeface="Noto Sans SC"/>
+                <a:ea typeface="Noto Sans SC"/>
+                <a:cs typeface="Noto Sans SC"/>
+              </a:rPr>
               <a:t>运行一个实验
 </a:t>
             </a:r>
           </a:p>
           <a:p xmlns:a="http://schemas.openxmlformats.org/drawingml/2006/main">
             <a:pPr algn="l">
+              <a:buNone/>
               <a:defRPr sz="2400">
                 <a:solidFill>
                   <a:srgbClr val="000000"/>
                 </a:solidFill>
-                <a:latin typeface="Helvetica Neue"/>
-                <a:ea typeface="Helvetica Neue"/>
-                <a:cs typeface="Helvetica Neue"/>
-              </a:defRPr>
-            </a:pPr>
-            <a:r>
+                <a:latin typeface="Noto Sans SC"/>
+                <a:ea typeface="Noto Sans SC"/>
+                <a:cs typeface="Noto Sans SC"/>
+              </a:defRPr>
+            </a:pPr>
+            <a:r>
+              <a:rPr sz="2400">
+                <a:solidFill>
+                  <a:srgbClr val="000000"/>
+                </a:solidFill>
+                <a:latin typeface="Noto Sans SC"/>
+                <a:ea typeface="Noto Sans SC"/>
+                <a:cs typeface="Noto Sans SC"/>
+              </a:rPr>
               <a:t>解释一次失败
 </a:t>
             </a:r>
           </a:p>
           <a:p xmlns:a="http://schemas.openxmlformats.org/drawingml/2006/main">
             <a:pPr algn="l">
+              <a:buNone/>
               <a:defRPr sz="2400">
                 <a:solidFill>
                   <a:srgbClr val="000000"/>
                 </a:solidFill>
-                <a:latin typeface="Helvetica Neue"/>
-                <a:ea typeface="Helvetica Neue"/>
-                <a:cs typeface="Helvetica Neue"/>
-              </a:defRPr>
-            </a:pPr>
-            <a:r>
+                <a:latin typeface="Noto Sans SC"/>
+                <a:ea typeface="Noto Sans SC"/>
+                <a:cs typeface="Noto Sans SC"/>
+              </a:defRPr>
+            </a:pPr>
+            <a:r>
+              <a:rPr sz="2400">
+                <a:solidFill>
+                  <a:srgbClr val="000000"/>
+                </a:solidFill>
+                <a:latin typeface="Noto Sans SC"/>
+                <a:ea typeface="Noto Sans SC"/>
+                <a:cs typeface="Noto Sans SC"/>
+              </a:rPr>
               <a:t>完成一次复盘</a:t>
             </a:r>
           </a:p>
@@ -5417,16 +6020,25 @@
           <a:lstStyle xmlns:a="http://schemas.openxmlformats.org/drawingml/2006/main"/>
           <a:p xmlns:a="http://schemas.openxmlformats.org/drawingml/2006/main">
             <a:pPr algn="l">
+              <a:buNone/>
               <a:defRPr sz="2400">
                 <a:solidFill>
                   <a:srgbClr val="000000"/>
                 </a:solidFill>
-                <a:latin typeface="Helvetica Neue"/>
-                <a:ea typeface="Helvetica Neue"/>
-                <a:cs typeface="Helvetica Neue"/>
-              </a:defRPr>
-            </a:pPr>
-            <a:r>
+                <a:latin typeface="Noto Sans SC"/>
+                <a:ea typeface="Noto Sans SC"/>
+                <a:cs typeface="Noto Sans SC"/>
+              </a:defRPr>
+            </a:pPr>
+            <a:r>
+              <a:rPr sz="2400">
+                <a:solidFill>
+                  <a:srgbClr val="000000"/>
+                </a:solidFill>
+                <a:latin typeface="Noto Sans SC"/>
+                <a:ea typeface="Noto Sans SC"/>
+                <a:cs typeface="Noto Sans SC"/>
+              </a:rPr>
               <a:t>结课行动</a:t>
             </a:r>
           </a:p>
@@ -5484,16 +6096,25 @@
           <a:lstStyle xmlns:a="http://schemas.openxmlformats.org/drawingml/2006/main"/>
           <a:p xmlns:a="http://schemas.openxmlformats.org/drawingml/2006/main">
             <a:pPr algn="r">
+              <a:buNone/>
               <a:defRPr sz="1000">
                 <a:solidFill>
                   <a:srgbClr val="000000"/>
                 </a:solidFill>
-                <a:latin typeface="Helvetica Neue"/>
-                <a:ea typeface="Helvetica Neue"/>
-                <a:cs typeface="Helvetica Neue"/>
-              </a:defRPr>
-            </a:pPr>
-            <a:r>
+                <a:latin typeface="Noto Sans SC"/>
+                <a:ea typeface="Noto Sans SC"/>
+                <a:cs typeface="Noto Sans SC"/>
+              </a:defRPr>
+            </a:pPr>
+            <a:r>
+              <a:rPr sz="1000">
+                <a:solidFill>
+                  <a:srgbClr val="000000"/>
+                </a:solidFill>
+                <a:latin typeface="Noto Sans SC"/>
+                <a:ea typeface="Noto Sans SC"/>
+                <a:cs typeface="Noto Sans SC"/>
+              </a:rPr>
               <a:t>2</a:t>
             </a:r>
           </a:p>
@@ -5529,16 +6150,25 @@
           <a:lstStyle xmlns:a="http://schemas.openxmlformats.org/drawingml/2006/main"/>
           <a:p xmlns:a="http://schemas.openxmlformats.org/drawingml/2006/main">
             <a:pPr algn="l">
+              <a:buNone/>
               <a:defRPr sz="2900">
                 <a:solidFill>
                   <a:srgbClr val="000000"/>
                 </a:solidFill>
-                <a:latin typeface="Helvetica Neue"/>
-                <a:ea typeface="Helvetica Neue"/>
-                <a:cs typeface="Helvetica Neue"/>
-              </a:defRPr>
-            </a:pPr>
-            <a:r>
+                <a:latin typeface="Noto Sans SC"/>
+                <a:ea typeface="Noto Sans SC"/>
+                <a:cs typeface="Noto Sans SC"/>
+              </a:defRPr>
+            </a:pPr>
+            <a:r>
+              <a:rPr sz="2900">
+                <a:solidFill>
+                  <a:srgbClr val="000000"/>
+                </a:solidFill>
+                <a:latin typeface="Noto Sans SC"/>
+                <a:ea typeface="Noto Sans SC"/>
+                <a:cs typeface="Noto Sans SC"/>
+              </a:rPr>
               <a:t>Agent 的价值不在“更会聊天”，而在受控地完成任务</a:t>
             </a:r>
           </a:p>
@@ -5574,31 +6204,49 @@
           <a:lstStyle xmlns:a="http://schemas.openxmlformats.org/drawingml/2006/main"/>
           <a:p xmlns:a="http://schemas.openxmlformats.org/drawingml/2006/main">
             <a:pPr algn="l">
+              <a:buNone/>
               <a:defRPr sz="2400">
                 <a:solidFill>
                   <a:srgbClr val="000000"/>
                 </a:solidFill>
-                <a:latin typeface="Helvetica Neue"/>
-                <a:ea typeface="Helvetica Neue"/>
-                <a:cs typeface="Helvetica Neue"/>
-              </a:defRPr>
-            </a:pPr>
-            <a:r>
+                <a:latin typeface="Noto Sans SC"/>
+                <a:ea typeface="Noto Sans SC"/>
+                <a:cs typeface="Noto Sans SC"/>
+              </a:defRPr>
+            </a:pPr>
+            <a:r>
+              <a:rPr sz="2400">
+                <a:solidFill>
+                  <a:srgbClr val="000000"/>
+                </a:solidFill>
+                <a:latin typeface="Noto Sans SC"/>
+                <a:ea typeface="Noto Sans SC"/>
+                <a:cs typeface="Noto Sans SC"/>
+              </a:rPr>
               <a:t>模型提供概率能力</a:t>
             </a:r>
           </a:p>
           <a:p xmlns:a="http://schemas.openxmlformats.org/drawingml/2006/main">
             <a:pPr algn="l">
+              <a:buNone/>
               <a:defRPr sz="2400">
                 <a:solidFill>
                   <a:srgbClr val="000000"/>
                 </a:solidFill>
-                <a:latin typeface="Helvetica Neue"/>
-                <a:ea typeface="Helvetica Neue"/>
-                <a:cs typeface="Helvetica Neue"/>
-              </a:defRPr>
-            </a:pPr>
-            <a:r>
+                <a:latin typeface="Noto Sans SC"/>
+                <a:ea typeface="Noto Sans SC"/>
+                <a:cs typeface="Noto Sans SC"/>
+              </a:defRPr>
+            </a:pPr>
+            <a:r>
+              <a:rPr sz="2400">
+                <a:solidFill>
+                  <a:srgbClr val="000000"/>
+                </a:solidFill>
+                <a:latin typeface="Noto Sans SC"/>
+                <a:ea typeface="Noto Sans SC"/>
+                <a:cs typeface="Noto Sans SC"/>
+              </a:rPr>
               <a:t>
 生成、理解、抽取与推理都存在不确定性；上下文不是数据库，也不是长期记忆。</a:t>
             </a:r>
@@ -5635,31 +6283,49 @@
           <a:lstStyle xmlns:a="http://schemas.openxmlformats.org/drawingml/2006/main"/>
           <a:p xmlns:a="http://schemas.openxmlformats.org/drawingml/2006/main">
             <a:pPr algn="l">
+              <a:buNone/>
               <a:defRPr sz="2400">
                 <a:solidFill>
                   <a:srgbClr val="000000"/>
                 </a:solidFill>
-                <a:latin typeface="Helvetica Neue"/>
-                <a:ea typeface="Helvetica Neue"/>
-                <a:cs typeface="Helvetica Neue"/>
-              </a:defRPr>
-            </a:pPr>
-            <a:r>
+                <a:latin typeface="Noto Sans SC"/>
+                <a:ea typeface="Noto Sans SC"/>
+                <a:cs typeface="Noto Sans SC"/>
+              </a:defRPr>
+            </a:pPr>
+            <a:r>
+              <a:rPr sz="2400">
+                <a:solidFill>
+                  <a:srgbClr val="000000"/>
+                </a:solidFill>
+                <a:latin typeface="Noto Sans SC"/>
+                <a:ea typeface="Noto Sans SC"/>
+                <a:cs typeface="Noto Sans SC"/>
+              </a:rPr>
               <a:t>系统提供可靠边界</a:t>
             </a:r>
           </a:p>
           <a:p xmlns:a="http://schemas.openxmlformats.org/drawingml/2006/main">
             <a:pPr algn="l">
+              <a:buNone/>
               <a:defRPr sz="2400">
                 <a:solidFill>
                   <a:srgbClr val="000000"/>
                 </a:solidFill>
-                <a:latin typeface="Helvetica Neue"/>
-                <a:ea typeface="Helvetica Neue"/>
-                <a:cs typeface="Helvetica Neue"/>
-              </a:defRPr>
-            </a:pPr>
-            <a:r>
+                <a:latin typeface="Noto Sans SC"/>
+                <a:ea typeface="Noto Sans SC"/>
+                <a:cs typeface="Noto Sans SC"/>
+              </a:defRPr>
+            </a:pPr>
+            <a:r>
+              <a:rPr sz="2400">
+                <a:solidFill>
+                  <a:srgbClr val="000000"/>
+                </a:solidFill>
+                <a:latin typeface="Noto Sans SC"/>
+                <a:ea typeface="Noto Sans SC"/>
+                <a:cs typeface="Noto Sans SC"/>
+              </a:rPr>
               <a:t>
 Runtime 管理工具、状态、权限、预算、终止、恢复与审计，才形成可交付能力。</a:t>
             </a:r>
@@ -5718,16 +6384,25 @@
           <a:lstStyle xmlns:a="http://schemas.openxmlformats.org/drawingml/2006/main"/>
           <a:p xmlns:a="http://schemas.openxmlformats.org/drawingml/2006/main">
             <a:pPr algn="r">
+              <a:buNone/>
               <a:defRPr sz="1000">
                 <a:solidFill>
                   <a:srgbClr val="000000"/>
                 </a:solidFill>
-                <a:latin typeface="Helvetica Neue"/>
-                <a:ea typeface="Helvetica Neue"/>
-                <a:cs typeface="Helvetica Neue"/>
-              </a:defRPr>
-            </a:pPr>
-            <a:r>
+                <a:latin typeface="Noto Sans SC"/>
+                <a:ea typeface="Noto Sans SC"/>
+                <a:cs typeface="Noto Sans SC"/>
+              </a:defRPr>
+            </a:pPr>
+            <a:r>
+              <a:rPr sz="1000">
+                <a:solidFill>
+                  <a:srgbClr val="000000"/>
+                </a:solidFill>
+                <a:latin typeface="Noto Sans SC"/>
+                <a:ea typeface="Noto Sans SC"/>
+                <a:cs typeface="Noto Sans SC"/>
+              </a:rPr>
               <a:t>3</a:t>
             </a:r>
           </a:p>
@@ -5763,16 +6438,25 @@
           <a:lstStyle xmlns:a="http://schemas.openxmlformats.org/drawingml/2006/main"/>
           <a:p xmlns:a="http://schemas.openxmlformats.org/drawingml/2006/main">
             <a:pPr algn="l">
+              <a:buNone/>
               <a:defRPr sz="2900">
                 <a:solidFill>
                   <a:srgbClr val="000000"/>
                 </a:solidFill>
-                <a:latin typeface="Helvetica Neue"/>
-                <a:ea typeface="Helvetica Neue"/>
-                <a:cs typeface="Helvetica Neue"/>
-              </a:defRPr>
-            </a:pPr>
-            <a:r>
+                <a:latin typeface="Noto Sans SC"/>
+                <a:ea typeface="Noto Sans SC"/>
+                <a:cs typeface="Noto Sans SC"/>
+              </a:defRPr>
+            </a:pPr>
+            <a:r>
+              <a:rPr sz="2900">
+                <a:solidFill>
+                  <a:srgbClr val="000000"/>
+                </a:solidFill>
+                <a:latin typeface="Noto Sans SC"/>
+                <a:ea typeface="Noto Sans SC"/>
+                <a:cs typeface="Noto Sans SC"/>
+              </a:rPr>
               <a:t>先分清三层责任，再讨论框架</a:t>
             </a:r>
           </a:p>
@@ -5808,31 +6492,49 @@
           <a:lstStyle xmlns:a="http://schemas.openxmlformats.org/drawingml/2006/main"/>
           <a:p xmlns:a="http://schemas.openxmlformats.org/drawingml/2006/main">
             <a:pPr algn="l">
+              <a:buNone/>
               <a:defRPr sz="2400">
                 <a:solidFill>
                   <a:srgbClr val="000000"/>
                 </a:solidFill>
-                <a:latin typeface="Helvetica Neue"/>
-                <a:ea typeface="Helvetica Neue"/>
-                <a:cs typeface="Helvetica Neue"/>
-              </a:defRPr>
-            </a:pPr>
-            <a:r>
+                <a:latin typeface="Noto Sans SC"/>
+                <a:ea typeface="Noto Sans SC"/>
+                <a:cs typeface="Noto Sans SC"/>
+              </a:defRPr>
+            </a:pPr>
+            <a:r>
+              <a:rPr sz="2400">
+                <a:solidFill>
+                  <a:srgbClr val="000000"/>
+                </a:solidFill>
+                <a:latin typeface="Noto Sans SC"/>
+                <a:ea typeface="Noto Sans SC"/>
+                <a:cs typeface="Noto Sans SC"/>
+              </a:rPr>
               <a:t>模型层</a:t>
             </a:r>
           </a:p>
           <a:p xmlns:a="http://schemas.openxmlformats.org/drawingml/2006/main">
             <a:pPr algn="l">
+              <a:buNone/>
               <a:defRPr sz="2400">
                 <a:solidFill>
                   <a:srgbClr val="000000"/>
                 </a:solidFill>
-                <a:latin typeface="Helvetica Neue"/>
-                <a:ea typeface="Helvetica Neue"/>
-                <a:cs typeface="Helvetica Neue"/>
-              </a:defRPr>
-            </a:pPr>
-            <a:r>
+                <a:latin typeface="Noto Sans SC"/>
+                <a:ea typeface="Noto Sans SC"/>
+                <a:cs typeface="Noto Sans SC"/>
+              </a:defRPr>
+            </a:pPr>
+            <a:r>
+              <a:rPr sz="2400">
+                <a:solidFill>
+                  <a:srgbClr val="000000"/>
+                </a:solidFill>
+                <a:latin typeface="Noto Sans SC"/>
+                <a:ea typeface="Noto Sans SC"/>
+                <a:cs typeface="Noto Sans SC"/>
+              </a:rPr>
               <a:t>
 Token、上下文、采样、向量与结构输出。</a:t>
             </a:r>
@@ -5869,31 +6571,49 @@
           <a:lstStyle xmlns:a="http://schemas.openxmlformats.org/drawingml/2006/main"/>
           <a:p xmlns:a="http://schemas.openxmlformats.org/drawingml/2006/main">
             <a:pPr algn="l">
+              <a:buNone/>
               <a:defRPr sz="2400">
                 <a:solidFill>
                   <a:srgbClr val="000000"/>
                 </a:solidFill>
-                <a:latin typeface="Helvetica Neue"/>
-                <a:ea typeface="Helvetica Neue"/>
-                <a:cs typeface="Helvetica Neue"/>
-              </a:defRPr>
-            </a:pPr>
-            <a:r>
+                <a:latin typeface="Noto Sans SC"/>
+                <a:ea typeface="Noto Sans SC"/>
+                <a:cs typeface="Noto Sans SC"/>
+              </a:defRPr>
+            </a:pPr>
+            <a:r>
+              <a:rPr sz="2400">
+                <a:solidFill>
+                  <a:srgbClr val="000000"/>
+                </a:solidFill>
+                <a:latin typeface="Noto Sans SC"/>
+                <a:ea typeface="Noto Sans SC"/>
+                <a:cs typeface="Noto Sans SC"/>
+              </a:rPr>
               <a:t>产品工程层</a:t>
             </a:r>
           </a:p>
           <a:p xmlns:a="http://schemas.openxmlformats.org/drawingml/2006/main">
             <a:pPr algn="l">
+              <a:buNone/>
               <a:defRPr sz="2400">
                 <a:solidFill>
                   <a:srgbClr val="000000"/>
                 </a:solidFill>
-                <a:latin typeface="Helvetica Neue"/>
-                <a:ea typeface="Helvetica Neue"/>
-                <a:cs typeface="Helvetica Neue"/>
-              </a:defRPr>
-            </a:pPr>
-            <a:r>
+                <a:latin typeface="Noto Sans SC"/>
+                <a:ea typeface="Noto Sans SC"/>
+                <a:cs typeface="Noto Sans SC"/>
+              </a:defRPr>
+            </a:pPr>
+            <a:r>
+              <a:rPr sz="2400">
+                <a:solidFill>
+                  <a:srgbClr val="000000"/>
+                </a:solidFill>
+                <a:latin typeface="Noto Sans SC"/>
+                <a:ea typeface="Noto Sans SC"/>
+                <a:cs typeface="Noto Sans SC"/>
+              </a:rPr>
               <a:t>
 权限、评估、观测、成本、部署与用户体验。</a:t>
             </a:r>
@@ -5930,31 +6650,49 @@
           <a:lstStyle xmlns:a="http://schemas.openxmlformats.org/drawingml/2006/main"/>
           <a:p xmlns:a="http://schemas.openxmlformats.org/drawingml/2006/main">
             <a:pPr algn="l">
+              <a:buNone/>
               <a:defRPr sz="2400">
                 <a:solidFill>
                   <a:srgbClr val="000000"/>
                 </a:solidFill>
-                <a:latin typeface="Helvetica Neue"/>
-                <a:ea typeface="Helvetica Neue"/>
-                <a:cs typeface="Helvetica Neue"/>
-              </a:defRPr>
-            </a:pPr>
-            <a:r>
+                <a:latin typeface="Noto Sans SC"/>
+                <a:ea typeface="Noto Sans SC"/>
+                <a:cs typeface="Noto Sans SC"/>
+              </a:defRPr>
+            </a:pPr>
+            <a:r>
+              <a:rPr sz="2400">
+                <a:solidFill>
+                  <a:srgbClr val="000000"/>
+                </a:solidFill>
+                <a:latin typeface="Noto Sans SC"/>
+                <a:ea typeface="Noto Sans SC"/>
+                <a:cs typeface="Noto Sans SC"/>
+              </a:rPr>
               <a:t>运行时层</a:t>
             </a:r>
           </a:p>
           <a:p xmlns:a="http://schemas.openxmlformats.org/drawingml/2006/main">
             <a:pPr algn="l">
+              <a:buNone/>
               <a:defRPr sz="2400">
                 <a:solidFill>
                   <a:srgbClr val="000000"/>
                 </a:solidFill>
-                <a:latin typeface="Helvetica Neue"/>
-                <a:ea typeface="Helvetica Neue"/>
-                <a:cs typeface="Helvetica Neue"/>
-              </a:defRPr>
-            </a:pPr>
-            <a:r>
+                <a:latin typeface="Noto Sans SC"/>
+                <a:ea typeface="Noto Sans SC"/>
+                <a:cs typeface="Noto Sans SC"/>
+              </a:defRPr>
+            </a:pPr>
+            <a:r>
+              <a:rPr sz="2400">
+                <a:solidFill>
+                  <a:srgbClr val="000000"/>
+                </a:solidFill>
+                <a:latin typeface="Noto Sans SC"/>
+                <a:ea typeface="Noto Sans SC"/>
+                <a:cs typeface="Noto Sans SC"/>
+              </a:rPr>
               <a:t>
 工具循环、状态机、检查点、审批与终止。</a:t>
             </a:r>
@@ -6011,16 +6749,25 @@
           <a:lstStyle xmlns:a="http://schemas.openxmlformats.org/drawingml/2006/main"/>
           <a:p xmlns:a="http://schemas.openxmlformats.org/drawingml/2006/main">
             <a:pPr algn="l">
+              <a:buNone/>
               <a:defRPr sz="1000">
                 <a:solidFill>
                   <a:srgbClr val="000000"/>
                 </a:solidFill>
-                <a:latin typeface="Helvetica Neue"/>
-                <a:ea typeface="Helvetica Neue"/>
-                <a:cs typeface="Helvetica Neue"/>
-              </a:defRPr>
-            </a:pPr>
-            <a:r>
+                <a:latin typeface="Noto Sans SC"/>
+                <a:ea typeface="Noto Sans SC"/>
+                <a:cs typeface="Noto Sans SC"/>
+              </a:defRPr>
+            </a:pPr>
+            <a:r>
+              <a:rPr sz="1000">
+                <a:solidFill>
+                  <a:srgbClr val="000000"/>
+                </a:solidFill>
+                <a:latin typeface="Noto Sans SC"/>
+                <a:ea typeface="Noto Sans SC"/>
+                <a:cs typeface="Noto Sans SC"/>
+              </a:rPr>
               <a:t>4</a:t>
             </a:r>
           </a:p>
@@ -6056,16 +6803,25 @@
           <a:lstStyle xmlns:a="http://schemas.openxmlformats.org/drawingml/2006/main"/>
           <a:p xmlns:a="http://schemas.openxmlformats.org/drawingml/2006/main">
             <a:pPr algn="l">
+              <a:buNone/>
               <a:defRPr sz="2900">
                 <a:solidFill>
                   <a:srgbClr val="000000"/>
                 </a:solidFill>
-                <a:latin typeface="Helvetica Neue"/>
-                <a:ea typeface="Helvetica Neue"/>
-                <a:cs typeface="Helvetica Neue"/>
-              </a:defRPr>
-            </a:pPr>
-            <a:r>
+                <a:latin typeface="Noto Sans SC"/>
+                <a:ea typeface="Noto Sans SC"/>
+                <a:cs typeface="Noto Sans SC"/>
+              </a:defRPr>
+            </a:pPr>
+            <a:r>
+              <a:rPr sz="2900">
+                <a:solidFill>
+                  <a:srgbClr val="000000"/>
+                </a:solidFill>
+                <a:latin typeface="Noto Sans SC"/>
+                <a:ea typeface="Noto Sans SC"/>
+                <a:cs typeface="Noto Sans SC"/>
+              </a:rPr>
               <a:t>学习顺序决定系统是否可控</a:t>
             </a:r>
           </a:p>
@@ -6073,7 +6829,7 @@
       </p:sp>
       <p:cxnSp>
         <p:nvCxnSpPr>
-          <p:cNvPr id="15" name="Google-Shape-2259-p159-4"/>
+          <p:cNvPr id="21" name="Google-Shape-2259-p159-4"/>
           <p:cNvCxnSpPr/>
           <p:nvPr/>
         </p:nvCxnSpPr>
@@ -6204,16 +6960,25 @@
           <a:lstStyle xmlns:a="http://schemas.openxmlformats.org/drawingml/2006/main"/>
           <a:p xmlns:a="http://schemas.openxmlformats.org/drawingml/2006/main">
             <a:pPr algn="l">
+              <a:buNone/>
               <a:defRPr sz="1600">
                 <a:solidFill>
                   <a:srgbClr val="000000"/>
                 </a:solidFill>
-                <a:latin typeface="Helvetica Neue"/>
-                <a:ea typeface="Helvetica Neue"/>
-                <a:cs typeface="Helvetica Neue"/>
-              </a:defRPr>
-            </a:pPr>
-            <a:r>
+                <a:latin typeface="Noto Sans SC"/>
+                <a:ea typeface="Noto Sans SC"/>
+                <a:cs typeface="Noto Sans SC"/>
+              </a:defRPr>
+            </a:pPr>
+            <a:r>
+              <a:rPr sz="1600">
+                <a:solidFill>
+                  <a:srgbClr val="000000"/>
+                </a:solidFill>
+                <a:latin typeface="Noto Sans SC"/>
+                <a:ea typeface="Noto Sans SC"/>
+                <a:cs typeface="Noto Sans SC"/>
+              </a:rPr>
               <a:t>第一阶段</a:t>
             </a:r>
           </a:p>
@@ -6249,16 +7014,25 @@
           <a:lstStyle xmlns:a="http://schemas.openxmlformats.org/drawingml/2006/main"/>
           <a:p xmlns:a="http://schemas.openxmlformats.org/drawingml/2006/main">
             <a:pPr algn="l">
+              <a:buNone/>
               <a:defRPr sz="1600">
                 <a:solidFill>
                   <a:srgbClr val="000000"/>
                 </a:solidFill>
-                <a:latin typeface="Helvetica Neue"/>
-                <a:ea typeface="Helvetica Neue"/>
-                <a:cs typeface="Helvetica Neue"/>
-              </a:defRPr>
-            </a:pPr>
-            <a:r>
+                <a:latin typeface="Noto Sans SC"/>
+                <a:ea typeface="Noto Sans SC"/>
+                <a:cs typeface="Noto Sans SC"/>
+              </a:defRPr>
+            </a:pPr>
+            <a:r>
+              <a:rPr sz="1600">
+                <a:solidFill>
+                  <a:srgbClr val="000000"/>
+                </a:solidFill>
+                <a:latin typeface="Noto Sans SC"/>
+                <a:ea typeface="Noto Sans SC"/>
+                <a:cs typeface="Noto Sans SC"/>
+              </a:rPr>
               <a:t>第二阶段</a:t>
             </a:r>
           </a:p>
@@ -6294,16 +7068,25 @@
           <a:lstStyle xmlns:a="http://schemas.openxmlformats.org/drawingml/2006/main"/>
           <a:p xmlns:a="http://schemas.openxmlformats.org/drawingml/2006/main">
             <a:pPr algn="l">
+              <a:buNone/>
               <a:defRPr sz="1600">
                 <a:solidFill>
                   <a:srgbClr val="000000"/>
                 </a:solidFill>
-                <a:latin typeface="Helvetica Neue"/>
-                <a:ea typeface="Helvetica Neue"/>
-                <a:cs typeface="Helvetica Neue"/>
-              </a:defRPr>
-            </a:pPr>
-            <a:r>
+                <a:latin typeface="Noto Sans SC"/>
+                <a:ea typeface="Noto Sans SC"/>
+                <a:cs typeface="Noto Sans SC"/>
+              </a:defRPr>
+            </a:pPr>
+            <a:r>
+              <a:rPr sz="1600">
+                <a:solidFill>
+                  <a:srgbClr val="000000"/>
+                </a:solidFill>
+                <a:latin typeface="Noto Sans SC"/>
+                <a:ea typeface="Noto Sans SC"/>
+                <a:cs typeface="Noto Sans SC"/>
+              </a:rPr>
               <a:t>第三阶段</a:t>
             </a:r>
           </a:p>
@@ -6339,31 +7122,49 @@
           <a:lstStyle xmlns:a="http://schemas.openxmlformats.org/drawingml/2006/main"/>
           <a:p xmlns:a="http://schemas.openxmlformats.org/drawingml/2006/main">
             <a:pPr algn="l">
+              <a:buNone/>
               <a:defRPr sz="2400">
                 <a:solidFill>
                   <a:srgbClr val="000000"/>
                 </a:solidFill>
-                <a:latin typeface="Helvetica Neue"/>
-                <a:ea typeface="Helvetica Neue"/>
-                <a:cs typeface="Helvetica Neue"/>
-              </a:defRPr>
-            </a:pPr>
-            <a:r>
+                <a:latin typeface="Noto Sans SC"/>
+                <a:ea typeface="Noto Sans SC"/>
+                <a:cs typeface="Noto Sans SC"/>
+              </a:defRPr>
+            </a:pPr>
+            <a:r>
+              <a:rPr sz="2400">
+                <a:solidFill>
+                  <a:srgbClr val="000000"/>
+                </a:solidFill>
+                <a:latin typeface="Noto Sans SC"/>
+                <a:ea typeface="Noto Sans SC"/>
+                <a:cs typeface="Noto Sans SC"/>
+              </a:rPr>
               <a:t>构建受控运行时</a:t>
             </a:r>
           </a:p>
           <a:p xmlns:a="http://schemas.openxmlformats.org/drawingml/2006/main">
             <a:pPr algn="l">
+              <a:buNone/>
               <a:defRPr sz="2400">
                 <a:solidFill>
                   <a:srgbClr val="000000"/>
                 </a:solidFill>
-                <a:latin typeface="Helvetica Neue"/>
-                <a:ea typeface="Helvetica Neue"/>
-                <a:cs typeface="Helvetica Neue"/>
-              </a:defRPr>
-            </a:pPr>
-            <a:r>
+                <a:latin typeface="Noto Sans SC"/>
+                <a:ea typeface="Noto Sans SC"/>
+                <a:cs typeface="Noto Sans SC"/>
+              </a:defRPr>
+            </a:pPr>
+            <a:r>
+              <a:rPr sz="2400">
+                <a:solidFill>
+                  <a:srgbClr val="000000"/>
+                </a:solidFill>
+                <a:latin typeface="Noto Sans SC"/>
+                <a:ea typeface="Noto Sans SC"/>
+                <a:cs typeface="Noto Sans SC"/>
+              </a:rPr>
               <a:t>
 结构、工具、状态</a:t>
             </a:r>
@@ -6400,31 +7201,49 @@
           <a:lstStyle xmlns:a="http://schemas.openxmlformats.org/drawingml/2006/main"/>
           <a:p xmlns:a="http://schemas.openxmlformats.org/drawingml/2006/main">
             <a:pPr algn="l">
+              <a:buNone/>
               <a:defRPr sz="2400">
                 <a:solidFill>
                   <a:srgbClr val="000000"/>
                 </a:solidFill>
-                <a:latin typeface="Helvetica Neue"/>
-                <a:ea typeface="Helvetica Neue"/>
-                <a:cs typeface="Helvetica Neue"/>
-              </a:defRPr>
-            </a:pPr>
-            <a:r>
+                <a:latin typeface="Noto Sans SC"/>
+                <a:ea typeface="Noto Sans SC"/>
+                <a:cs typeface="Noto Sans SC"/>
+              </a:defRPr>
+            </a:pPr>
+            <a:r>
+              <a:rPr sz="2400">
+                <a:solidFill>
+                  <a:srgbClr val="000000"/>
+                </a:solidFill>
+                <a:latin typeface="Noto Sans SC"/>
+                <a:ea typeface="Noto Sans SC"/>
+                <a:cs typeface="Noto Sans SC"/>
+              </a:rPr>
               <a:t>理解模型边界</a:t>
             </a:r>
           </a:p>
           <a:p xmlns:a="http://schemas.openxmlformats.org/drawingml/2006/main">
             <a:pPr algn="l">
+              <a:buNone/>
               <a:defRPr sz="2400">
                 <a:solidFill>
                   <a:srgbClr val="000000"/>
                 </a:solidFill>
-                <a:latin typeface="Helvetica Neue"/>
-                <a:ea typeface="Helvetica Neue"/>
-                <a:cs typeface="Helvetica Neue"/>
-              </a:defRPr>
-            </a:pPr>
-            <a:r>
+                <a:latin typeface="Noto Sans SC"/>
+                <a:ea typeface="Noto Sans SC"/>
+                <a:cs typeface="Noto Sans SC"/>
+              </a:defRPr>
+            </a:pPr>
+            <a:r>
+              <a:rPr sz="2400">
+                <a:solidFill>
+                  <a:srgbClr val="000000"/>
+                </a:solidFill>
+                <a:latin typeface="Noto Sans SC"/>
+                <a:ea typeface="Noto Sans SC"/>
+                <a:cs typeface="Noto Sans SC"/>
+              </a:rPr>
               <a:t>
 Token、采样、向量</a:t>
             </a:r>
@@ -6461,31 +7280,49 @@
           <a:lstStyle xmlns:a="http://schemas.openxmlformats.org/drawingml/2006/main"/>
           <a:p xmlns:a="http://schemas.openxmlformats.org/drawingml/2006/main">
             <a:pPr algn="l">
+              <a:buNone/>
               <a:defRPr sz="2400">
                 <a:solidFill>
                   <a:srgbClr val="000000"/>
                 </a:solidFill>
-                <a:latin typeface="Helvetica Neue"/>
-                <a:ea typeface="Helvetica Neue"/>
-                <a:cs typeface="Helvetica Neue"/>
-              </a:defRPr>
-            </a:pPr>
-            <a:r>
+                <a:latin typeface="Noto Sans SC"/>
+                <a:ea typeface="Noto Sans SC"/>
+                <a:cs typeface="Noto Sans SC"/>
+              </a:defRPr>
+            </a:pPr>
+            <a:r>
+              <a:rPr sz="2400">
+                <a:solidFill>
+                  <a:srgbClr val="000000"/>
+                </a:solidFill>
+                <a:latin typeface="Noto Sans SC"/>
+                <a:ea typeface="Noto Sans SC"/>
+                <a:cs typeface="Noto Sans SC"/>
+              </a:rPr>
               <a:t>建立生产证据</a:t>
             </a:r>
           </a:p>
           <a:p xmlns:a="http://schemas.openxmlformats.org/drawingml/2006/main">
             <a:pPr algn="l">
+              <a:buNone/>
               <a:defRPr sz="2400">
                 <a:solidFill>
                   <a:srgbClr val="000000"/>
                 </a:solidFill>
-                <a:latin typeface="Helvetica Neue"/>
-                <a:ea typeface="Helvetica Neue"/>
-                <a:cs typeface="Helvetica Neue"/>
-              </a:defRPr>
-            </a:pPr>
-            <a:r>
+                <a:latin typeface="Noto Sans SC"/>
+                <a:ea typeface="Noto Sans SC"/>
+                <a:cs typeface="Noto Sans SC"/>
+              </a:defRPr>
+            </a:pPr>
+            <a:r>
+              <a:rPr sz="2400">
+                <a:solidFill>
+                  <a:srgbClr val="000000"/>
+                </a:solidFill>
+                <a:latin typeface="Noto Sans SC"/>
+                <a:ea typeface="Noto Sans SC"/>
+                <a:cs typeface="Noto Sans SC"/>
+              </a:rPr>
               <a:t>
 测试、安全、观测</a:t>
             </a:r>
@@ -6542,16 +7379,25 @@
           <a:lstStyle xmlns:a="http://schemas.openxmlformats.org/drawingml/2006/main"/>
           <a:p xmlns:a="http://schemas.openxmlformats.org/drawingml/2006/main">
             <a:pPr algn="r">
+              <a:buNone/>
               <a:defRPr sz="1000">
                 <a:solidFill>
                   <a:srgbClr val="000000"/>
                 </a:solidFill>
-                <a:latin typeface="Helvetica Neue"/>
-                <a:ea typeface="Helvetica Neue"/>
-                <a:cs typeface="Helvetica Neue"/>
-              </a:defRPr>
-            </a:pPr>
-            <a:r>
+                <a:latin typeface="Noto Sans SC"/>
+                <a:ea typeface="Noto Sans SC"/>
+                <a:cs typeface="Noto Sans SC"/>
+              </a:defRPr>
+            </a:pPr>
+            <a:r>
+              <a:rPr sz="1000">
+                <a:solidFill>
+                  <a:srgbClr val="000000"/>
+                </a:solidFill>
+                <a:latin typeface="Noto Sans SC"/>
+                <a:ea typeface="Noto Sans SC"/>
+                <a:cs typeface="Noto Sans SC"/>
+              </a:rPr>
               <a:t>5</a:t>
             </a:r>
           </a:p>
@@ -6587,16 +7433,25 @@
           <a:lstStyle xmlns:a="http://schemas.openxmlformats.org/drawingml/2006/main"/>
           <a:p xmlns:a="http://schemas.openxmlformats.org/drawingml/2006/main">
             <a:pPr algn="l">
+              <a:buNone/>
               <a:defRPr sz="2900">
                 <a:solidFill>
                   <a:srgbClr val="000000"/>
                 </a:solidFill>
-                <a:latin typeface="Helvetica Neue"/>
-                <a:ea typeface="Helvetica Neue"/>
-                <a:cs typeface="Helvetica Neue"/>
-              </a:defRPr>
-            </a:pPr>
-            <a:r>
+                <a:latin typeface="Noto Sans SC"/>
+                <a:ea typeface="Noto Sans SC"/>
+                <a:cs typeface="Noto Sans SC"/>
+              </a:defRPr>
+            </a:pPr>
+            <a:r>
+              <a:rPr sz="2900">
+                <a:solidFill>
+                  <a:srgbClr val="000000"/>
+                </a:solidFill>
+                <a:latin typeface="Noto Sans SC"/>
+                <a:ea typeface="Noto Sans SC"/>
+                <a:cs typeface="Noto Sans SC"/>
+              </a:rPr>
               <a:t>Context Engineering 管理进入决策的全部信息</a:t>
             </a:r>
           </a:p>
@@ -6630,31 +7485,49 @@
           <a:lstStyle xmlns:a="http://schemas.openxmlformats.org/drawingml/2006/main"/>
           <a:p xmlns:a="http://schemas.openxmlformats.org/drawingml/2006/main">
             <a:pPr algn="l">
+              <a:buNone/>
               <a:defRPr sz="2400">
                 <a:solidFill>
                   <a:srgbClr val="000000"/>
                 </a:solidFill>
-                <a:latin typeface="Helvetica Neue"/>
-                <a:ea typeface="Helvetica Neue"/>
-                <a:cs typeface="Helvetica Neue"/>
-              </a:defRPr>
-            </a:pPr>
-            <a:r>
+                <a:latin typeface="Noto Sans SC"/>
+                <a:ea typeface="Noto Sans SC"/>
+                <a:cs typeface="Noto Sans SC"/>
+              </a:defRPr>
+            </a:pPr>
+            <a:r>
+              <a:rPr sz="2400">
+                <a:solidFill>
+                  <a:srgbClr val="000000"/>
+                </a:solidFill>
+                <a:latin typeface="Noto Sans SC"/>
+                <a:ea typeface="Noto Sans SC"/>
+                <a:cs typeface="Noto Sans SC"/>
+              </a:rPr>
               <a:t>指令</a:t>
             </a:r>
           </a:p>
           <a:p xmlns:a="http://schemas.openxmlformats.org/drawingml/2006/main">
             <a:pPr algn="l">
+              <a:buNone/>
               <a:defRPr sz="2400">
                 <a:solidFill>
                   <a:srgbClr val="000000"/>
                 </a:solidFill>
-                <a:latin typeface="Helvetica Neue"/>
-                <a:ea typeface="Helvetica Neue"/>
-                <a:cs typeface="Helvetica Neue"/>
-              </a:defRPr>
-            </a:pPr>
-            <a:r>
+                <a:latin typeface="Noto Sans SC"/>
+                <a:ea typeface="Noto Sans SC"/>
+                <a:cs typeface="Noto Sans SC"/>
+              </a:defRPr>
+            </a:pPr>
+            <a:r>
+              <a:rPr sz="2400">
+                <a:solidFill>
+                  <a:srgbClr val="000000"/>
+                </a:solidFill>
+                <a:latin typeface="Noto Sans SC"/>
+                <a:ea typeface="Noto Sans SC"/>
+                <a:cs typeface="Noto Sans SC"/>
+              </a:rPr>
               <a:t>
 优先级、角色、输出契约</a:t>
             </a:r>
@@ -6689,31 +7562,49 @@
           <a:lstStyle xmlns:a="http://schemas.openxmlformats.org/drawingml/2006/main"/>
           <a:p xmlns:a="http://schemas.openxmlformats.org/drawingml/2006/main">
             <a:pPr algn="l">
+              <a:buNone/>
               <a:defRPr sz="2400">
                 <a:solidFill>
                   <a:srgbClr val="000000"/>
                 </a:solidFill>
-                <a:latin typeface="Helvetica Neue"/>
-                <a:ea typeface="Helvetica Neue"/>
-                <a:cs typeface="Helvetica Neue"/>
-              </a:defRPr>
-            </a:pPr>
-            <a:r>
+                <a:latin typeface="Noto Sans SC"/>
+                <a:ea typeface="Noto Sans SC"/>
+                <a:cs typeface="Noto Sans SC"/>
+              </a:defRPr>
+            </a:pPr>
+            <a:r>
+              <a:rPr sz="2400">
+                <a:solidFill>
+                  <a:srgbClr val="000000"/>
+                </a:solidFill>
+                <a:latin typeface="Noto Sans SC"/>
+                <a:ea typeface="Noto Sans SC"/>
+                <a:cs typeface="Noto Sans SC"/>
+              </a:rPr>
               <a:t>知识</a:t>
             </a:r>
           </a:p>
           <a:p xmlns:a="http://schemas.openxmlformats.org/drawingml/2006/main">
             <a:pPr algn="l">
+              <a:buNone/>
               <a:defRPr sz="2400">
                 <a:solidFill>
                   <a:srgbClr val="000000"/>
                 </a:solidFill>
-                <a:latin typeface="Helvetica Neue"/>
-                <a:ea typeface="Helvetica Neue"/>
-                <a:cs typeface="Helvetica Neue"/>
-              </a:defRPr>
-            </a:pPr>
-            <a:r>
+                <a:latin typeface="Noto Sans SC"/>
+                <a:ea typeface="Noto Sans SC"/>
+                <a:cs typeface="Noto Sans SC"/>
+              </a:defRPr>
+            </a:pPr>
+            <a:r>
+              <a:rPr sz="2400">
+                <a:solidFill>
+                  <a:srgbClr val="000000"/>
+                </a:solidFill>
+                <a:latin typeface="Noto Sans SC"/>
+                <a:ea typeface="Noto Sans SC"/>
+                <a:cs typeface="Noto Sans SC"/>
+              </a:rPr>
               <a:t>
 检索结果、引用与版本</a:t>
             </a:r>
@@ -6750,31 +7641,49 @@
           <a:lstStyle xmlns:a="http://schemas.openxmlformats.org/drawingml/2006/main"/>
           <a:p xmlns:a="http://schemas.openxmlformats.org/drawingml/2006/main">
             <a:pPr algn="l">
+              <a:buNone/>
               <a:defRPr sz="2400">
                 <a:solidFill>
                   <a:srgbClr val="000000"/>
                 </a:solidFill>
-                <a:latin typeface="Helvetica Neue"/>
-                <a:ea typeface="Helvetica Neue"/>
-                <a:cs typeface="Helvetica Neue"/>
-              </a:defRPr>
-            </a:pPr>
-            <a:r>
+                <a:latin typeface="Noto Sans SC"/>
+                <a:ea typeface="Noto Sans SC"/>
+                <a:cs typeface="Noto Sans SC"/>
+              </a:defRPr>
+            </a:pPr>
+            <a:r>
+              <a:rPr sz="2400">
+                <a:solidFill>
+                  <a:srgbClr val="000000"/>
+                </a:solidFill>
+                <a:latin typeface="Noto Sans SC"/>
+                <a:ea typeface="Noto Sans SC"/>
+                <a:cs typeface="Noto Sans SC"/>
+              </a:rPr>
               <a:t>状态</a:t>
             </a:r>
           </a:p>
           <a:p xmlns:a="http://schemas.openxmlformats.org/drawingml/2006/main">
             <a:pPr algn="l">
+              <a:buNone/>
               <a:defRPr sz="2400">
                 <a:solidFill>
                   <a:srgbClr val="000000"/>
                 </a:solidFill>
-                <a:latin typeface="Helvetica Neue"/>
-                <a:ea typeface="Helvetica Neue"/>
-                <a:cs typeface="Helvetica Neue"/>
-              </a:defRPr>
-            </a:pPr>
-            <a:r>
+                <a:latin typeface="Noto Sans SC"/>
+                <a:ea typeface="Noto Sans SC"/>
+                <a:cs typeface="Noto Sans SC"/>
+              </a:defRPr>
+            </a:pPr>
+            <a:r>
+              <a:rPr sz="2400">
+                <a:solidFill>
+                  <a:srgbClr val="000000"/>
+                </a:solidFill>
+                <a:latin typeface="Noto Sans SC"/>
+                <a:ea typeface="Noto Sans SC"/>
+                <a:cs typeface="Noto Sans SC"/>
+              </a:rPr>
               <a:t>
 会话、任务、记忆与审批</a:t>
             </a:r>
@@ -6811,31 +7720,49 @@
           <a:lstStyle xmlns:a="http://schemas.openxmlformats.org/drawingml/2006/main"/>
           <a:p xmlns:a="http://schemas.openxmlformats.org/drawingml/2006/main">
             <a:pPr algn="l">
+              <a:buNone/>
               <a:defRPr sz="2400">
                 <a:solidFill>
                   <a:srgbClr val="000000"/>
                 </a:solidFill>
-                <a:latin typeface="Helvetica Neue"/>
-                <a:ea typeface="Helvetica Neue"/>
-                <a:cs typeface="Helvetica Neue"/>
-              </a:defRPr>
-            </a:pPr>
-            <a:r>
+                <a:latin typeface="Noto Sans SC"/>
+                <a:ea typeface="Noto Sans SC"/>
+                <a:cs typeface="Noto Sans SC"/>
+              </a:defRPr>
+            </a:pPr>
+            <a:r>
+              <a:rPr sz="2400">
+                <a:solidFill>
+                  <a:srgbClr val="000000"/>
+                </a:solidFill>
+                <a:latin typeface="Noto Sans SC"/>
+                <a:ea typeface="Noto Sans SC"/>
+                <a:cs typeface="Noto Sans SC"/>
+              </a:rPr>
               <a:t>预算</a:t>
             </a:r>
           </a:p>
           <a:p xmlns:a="http://schemas.openxmlformats.org/drawingml/2006/main">
             <a:pPr algn="l">
+              <a:buNone/>
               <a:defRPr sz="2400">
                 <a:solidFill>
                   <a:srgbClr val="000000"/>
                 </a:solidFill>
-                <a:latin typeface="Helvetica Neue"/>
-                <a:ea typeface="Helvetica Neue"/>
-                <a:cs typeface="Helvetica Neue"/>
-              </a:defRPr>
-            </a:pPr>
-            <a:r>
+                <a:latin typeface="Noto Sans SC"/>
+                <a:ea typeface="Noto Sans SC"/>
+                <a:cs typeface="Noto Sans SC"/>
+              </a:defRPr>
+            </a:pPr>
+            <a:r>
+              <a:rPr sz="2400">
+                <a:solidFill>
+                  <a:srgbClr val="000000"/>
+                </a:solidFill>
+                <a:latin typeface="Noto Sans SC"/>
+                <a:ea typeface="Noto Sans SC"/>
+                <a:cs typeface="Noto Sans SC"/>
+              </a:rPr>
               <a:t>
 长度、成本、延迟与截断</a:t>
             </a:r>
@@ -6894,16 +7821,25 @@
           <a:lstStyle xmlns:a="http://schemas.openxmlformats.org/drawingml/2006/main"/>
           <a:p xmlns:a="http://schemas.openxmlformats.org/drawingml/2006/main">
             <a:pPr algn="r">
+              <a:buNone/>
               <a:defRPr sz="1000">
                 <a:solidFill>
                   <a:srgbClr val="000000"/>
                 </a:solidFill>
-                <a:latin typeface="Helvetica Neue"/>
-                <a:ea typeface="Helvetica Neue"/>
-                <a:cs typeface="Helvetica Neue"/>
-              </a:defRPr>
-            </a:pPr>
-            <a:r>
+                <a:latin typeface="Noto Sans SC"/>
+                <a:ea typeface="Noto Sans SC"/>
+                <a:cs typeface="Noto Sans SC"/>
+              </a:defRPr>
+            </a:pPr>
+            <a:r>
+              <a:rPr sz="1000">
+                <a:solidFill>
+                  <a:srgbClr val="000000"/>
+                </a:solidFill>
+                <a:latin typeface="Noto Sans SC"/>
+                <a:ea typeface="Noto Sans SC"/>
+                <a:cs typeface="Noto Sans SC"/>
+              </a:rPr>
               <a:t>6</a:t>
             </a:r>
           </a:p>
@@ -6939,16 +7875,25 @@
           <a:lstStyle xmlns:a="http://schemas.openxmlformats.org/drawingml/2006/main"/>
           <a:p xmlns:a="http://schemas.openxmlformats.org/drawingml/2006/main">
             <a:pPr algn="l">
+              <a:buNone/>
               <a:defRPr sz="2900">
                 <a:solidFill>
                   <a:srgbClr val="000000"/>
                 </a:solidFill>
-                <a:latin typeface="Helvetica Neue"/>
-                <a:ea typeface="Helvetica Neue"/>
-                <a:cs typeface="Helvetica Neue"/>
-              </a:defRPr>
-            </a:pPr>
-            <a:r>
+                <a:latin typeface="Noto Sans SC"/>
+                <a:ea typeface="Noto Sans SC"/>
+                <a:cs typeface="Noto Sans SC"/>
+              </a:defRPr>
+            </a:pPr>
+            <a:r>
+              <a:rPr sz="2900">
+                <a:solidFill>
+                  <a:srgbClr val="000000"/>
+                </a:solidFill>
+                <a:latin typeface="Noto Sans SC"/>
+                <a:ea typeface="Noto Sans SC"/>
+                <a:cs typeface="Noto Sans SC"/>
+              </a:rPr>
               <a:t>Tool Calling 是受控执行协议，不是模型直接运行代码</a:t>
             </a:r>
           </a:p>
@@ -6984,16 +7929,25 @@
           <a:lstStyle xmlns:a="http://schemas.openxmlformats.org/drawingml/2006/main"/>
           <a:p xmlns:a="http://schemas.openxmlformats.org/drawingml/2006/main">
             <a:pPr algn="l">
+              <a:buNone/>
               <a:defRPr sz="2400">
                 <a:solidFill>
                   <a:srgbClr val="000000"/>
                 </a:solidFill>
-                <a:latin typeface="Helvetica Neue"/>
-                <a:ea typeface="Helvetica Neue"/>
-                <a:cs typeface="Helvetica Neue"/>
-              </a:defRPr>
-            </a:pPr>
-            <a:r>
+                <a:latin typeface="Noto Sans SC"/>
+                <a:ea typeface="Noto Sans SC"/>
+                <a:cs typeface="Noto Sans SC"/>
+              </a:defRPr>
+            </a:pPr>
+            <a:r>
+              <a:rPr sz="2400">
+                <a:solidFill>
+                  <a:srgbClr val="000000"/>
+                </a:solidFill>
+                <a:latin typeface="Noto Sans SC"/>
+                <a:ea typeface="Noto Sans SC"/>
+                <a:cs typeface="Noto Sans SC"/>
+              </a:rPr>
               <a:t>模型提出调用</a:t>
             </a:r>
           </a:p>
@@ -7029,16 +7983,25 @@
           <a:lstStyle xmlns:a="http://schemas.openxmlformats.org/drawingml/2006/main"/>
           <a:p xmlns:a="http://schemas.openxmlformats.org/drawingml/2006/main">
             <a:pPr algn="l">
+              <a:buNone/>
               <a:defRPr sz="2400">
                 <a:solidFill>
                   <a:srgbClr val="000000"/>
                 </a:solidFill>
-                <a:latin typeface="Helvetica Neue"/>
-                <a:ea typeface="Helvetica Neue"/>
-                <a:cs typeface="Helvetica Neue"/>
-              </a:defRPr>
-            </a:pPr>
-            <a:r>
+                <a:latin typeface="Noto Sans SC"/>
+                <a:ea typeface="Noto Sans SC"/>
+                <a:cs typeface="Noto Sans SC"/>
+              </a:defRPr>
+            </a:pPr>
+            <a:r>
+              <a:rPr sz="2400">
+                <a:solidFill>
+                  <a:srgbClr val="000000"/>
+                </a:solidFill>
+                <a:latin typeface="Noto Sans SC"/>
+                <a:ea typeface="Noto Sans SC"/>
+                <a:cs typeface="Noto Sans SC"/>
+              </a:rPr>
               <a:t>01</a:t>
             </a:r>
           </a:p>
@@ -7074,16 +8037,25 @@
           <a:lstStyle xmlns:a="http://schemas.openxmlformats.org/drawingml/2006/main"/>
           <a:p xmlns:a="http://schemas.openxmlformats.org/drawingml/2006/main">
             <a:pPr algn="l">
+              <a:buNone/>
               <a:defRPr sz="2400">
                 <a:solidFill>
                   <a:srgbClr val="000000"/>
                 </a:solidFill>
-                <a:latin typeface="Helvetica Neue"/>
-                <a:ea typeface="Helvetica Neue"/>
-                <a:cs typeface="Helvetica Neue"/>
-              </a:defRPr>
-            </a:pPr>
-            <a:r>
+                <a:latin typeface="Noto Sans SC"/>
+                <a:ea typeface="Noto Sans SC"/>
+                <a:cs typeface="Noto Sans SC"/>
+              </a:defRPr>
+            </a:pPr>
+            <a:r>
+              <a:rPr sz="2400">
+                <a:solidFill>
+                  <a:srgbClr val="000000"/>
+                </a:solidFill>
+                <a:latin typeface="Noto Sans SC"/>
+                <a:ea typeface="Noto Sans SC"/>
+                <a:cs typeface="Noto Sans SC"/>
+              </a:rPr>
               <a:t>Runtime 校验与授权</a:t>
             </a:r>
           </a:p>
@@ -7119,16 +8091,25 @@
           <a:lstStyle xmlns:a="http://schemas.openxmlformats.org/drawingml/2006/main"/>
           <a:p xmlns:a="http://schemas.openxmlformats.org/drawingml/2006/main">
             <a:pPr algn="l">
+              <a:buNone/>
               <a:defRPr sz="2400">
                 <a:solidFill>
                   <a:srgbClr val="000000"/>
                 </a:solidFill>
-                <a:latin typeface="Helvetica Neue"/>
-                <a:ea typeface="Helvetica Neue"/>
-                <a:cs typeface="Helvetica Neue"/>
-              </a:defRPr>
-            </a:pPr>
-            <a:r>
+                <a:latin typeface="Noto Sans SC"/>
+                <a:ea typeface="Noto Sans SC"/>
+                <a:cs typeface="Noto Sans SC"/>
+              </a:defRPr>
+            </a:pPr>
+            <a:r>
+              <a:rPr sz="2400">
+                <a:solidFill>
+                  <a:srgbClr val="000000"/>
+                </a:solidFill>
+                <a:latin typeface="Noto Sans SC"/>
+                <a:ea typeface="Noto Sans SC"/>
+                <a:cs typeface="Noto Sans SC"/>
+              </a:rPr>
               <a:t>02</a:t>
             </a:r>
           </a:p>
@@ -7164,16 +8145,25 @@
           <a:lstStyle xmlns:a="http://schemas.openxmlformats.org/drawingml/2006/main"/>
           <a:p xmlns:a="http://schemas.openxmlformats.org/drawingml/2006/main">
             <a:pPr algn="l">
+              <a:buNone/>
               <a:defRPr sz="2400">
                 <a:solidFill>
                   <a:srgbClr val="000000"/>
                 </a:solidFill>
-                <a:latin typeface="Helvetica Neue"/>
-                <a:ea typeface="Helvetica Neue"/>
-                <a:cs typeface="Helvetica Neue"/>
-              </a:defRPr>
-            </a:pPr>
-            <a:r>
+                <a:latin typeface="Noto Sans SC"/>
+                <a:ea typeface="Noto Sans SC"/>
+                <a:cs typeface="Noto Sans SC"/>
+              </a:defRPr>
+            </a:pPr>
+            <a:r>
+              <a:rPr sz="2400">
+                <a:solidFill>
+                  <a:srgbClr val="000000"/>
+                </a:solidFill>
+                <a:latin typeface="Noto Sans SC"/>
+                <a:ea typeface="Noto Sans SC"/>
+                <a:cs typeface="Noto Sans SC"/>
+              </a:rPr>
               <a:t>工具执行并返回观察</a:t>
             </a:r>
           </a:p>
@@ -7209,16 +8199,25 @@
           <a:lstStyle xmlns:a="http://schemas.openxmlformats.org/drawingml/2006/main"/>
           <a:p xmlns:a="http://schemas.openxmlformats.org/drawingml/2006/main">
             <a:pPr algn="l">
+              <a:buNone/>
               <a:defRPr sz="2400">
                 <a:solidFill>
                   <a:srgbClr val="000000"/>
                 </a:solidFill>
-                <a:latin typeface="Helvetica Neue"/>
-                <a:ea typeface="Helvetica Neue"/>
-                <a:cs typeface="Helvetica Neue"/>
-              </a:defRPr>
-            </a:pPr>
-            <a:r>
+                <a:latin typeface="Noto Sans SC"/>
+                <a:ea typeface="Noto Sans SC"/>
+                <a:cs typeface="Noto Sans SC"/>
+              </a:defRPr>
+            </a:pPr>
+            <a:r>
+              <a:rPr sz="2400">
+                <a:solidFill>
+                  <a:srgbClr val="000000"/>
+                </a:solidFill>
+                <a:latin typeface="Noto Sans SC"/>
+                <a:ea typeface="Noto Sans SC"/>
+                <a:cs typeface="Noto Sans SC"/>
+              </a:rPr>
               <a:t>03</a:t>
             </a:r>
           </a:p>
@@ -7254,16 +8253,25 @@
           <a:lstStyle xmlns:a="http://schemas.openxmlformats.org/drawingml/2006/main"/>
           <a:p xmlns:a="http://schemas.openxmlformats.org/drawingml/2006/main">
             <a:pPr algn="l">
+              <a:buNone/>
               <a:defRPr sz="2400">
                 <a:solidFill>
                   <a:srgbClr val="000000"/>
                 </a:solidFill>
-                <a:latin typeface="Helvetica Neue"/>
-                <a:ea typeface="Helvetica Neue"/>
-                <a:cs typeface="Helvetica Neue"/>
-              </a:defRPr>
-            </a:pPr>
-            <a:r>
+                <a:latin typeface="Noto Sans SC"/>
+                <a:ea typeface="Noto Sans SC"/>
+                <a:cs typeface="Noto Sans SC"/>
+              </a:defRPr>
+            </a:pPr>
+            <a:r>
+              <a:rPr sz="2400">
+                <a:solidFill>
+                  <a:srgbClr val="000000"/>
+                </a:solidFill>
+                <a:latin typeface="Noto Sans SC"/>
+                <a:ea typeface="Noto Sans SC"/>
+                <a:cs typeface="Noto Sans SC"/>
+              </a:rPr>
               <a:t>终止、重试或审批</a:t>
             </a:r>
           </a:p>
@@ -7299,16 +8307,25 @@
           <a:lstStyle xmlns:a="http://schemas.openxmlformats.org/drawingml/2006/main"/>
           <a:p xmlns:a="http://schemas.openxmlformats.org/drawingml/2006/main">
             <a:pPr algn="l">
+              <a:buNone/>
               <a:defRPr sz="2400">
                 <a:solidFill>
                   <a:srgbClr val="000000"/>
                 </a:solidFill>
-                <a:latin typeface="Helvetica Neue"/>
-                <a:ea typeface="Helvetica Neue"/>
-                <a:cs typeface="Helvetica Neue"/>
-              </a:defRPr>
-            </a:pPr>
-            <a:r>
+                <a:latin typeface="Noto Sans SC"/>
+                <a:ea typeface="Noto Sans SC"/>
+                <a:cs typeface="Noto Sans SC"/>
+              </a:defRPr>
+            </a:pPr>
+            <a:r>
+              <a:rPr sz="2400">
+                <a:solidFill>
+                  <a:srgbClr val="000000"/>
+                </a:solidFill>
+                <a:latin typeface="Noto Sans SC"/>
+                <a:ea typeface="Noto Sans SC"/>
+                <a:cs typeface="Noto Sans SC"/>
+              </a:rPr>
               <a:t>04</a:t>
             </a:r>
           </a:p>
@@ -7344,37 +8361,56 @@
           <a:lstStyle xmlns:a="http://schemas.openxmlformats.org/drawingml/2006/main"/>
           <a:p xmlns:a="http://schemas.openxmlformats.org/drawingml/2006/main">
             <a:pPr algn="l">
+              <a:buNone/>
               <a:defRPr sz="2400">
                 <a:solidFill>
                   <a:srgbClr val="000000"/>
                 </a:solidFill>
-                <a:latin typeface="Helvetica Neue"/>
-                <a:ea typeface="Helvetica Neue"/>
-                <a:cs typeface="Helvetica Neue"/>
-              </a:defRPr>
-            </a:pPr>
-            <a:r>
+                <a:latin typeface="Noto Sans SC"/>
+                <a:ea typeface="Noto Sans SC"/>
+                <a:cs typeface="Noto Sans SC"/>
+              </a:defRPr>
+            </a:pPr>
+            <a:r>
+              <a:rPr sz="2400">
+                <a:solidFill>
+                  <a:srgbClr val="000000"/>
+                </a:solidFill>
+                <a:latin typeface="Noto Sans SC"/>
+                <a:ea typeface="Noto Sans SC"/>
+                <a:cs typeface="Noto Sans SC"/>
+              </a:rPr>
               <a:t>Runtime 承担执行责任</a:t>
             </a:r>
           </a:p>
           <a:p xmlns:a="http://schemas.openxmlformats.org/drawingml/2006/main">
             <a:pPr algn="l">
+              <a:buNone/>
               <a:defRPr sz="2400">
                 <a:solidFill>
                   <a:srgbClr val="000000"/>
                 </a:solidFill>
-                <a:latin typeface="Helvetica Neue"/>
-                <a:ea typeface="Helvetica Neue"/>
-                <a:cs typeface="Helvetica Neue"/>
-              </a:defRPr>
-            </a:pPr>
-            <a:r>
+                <a:latin typeface="Noto Sans SC"/>
+                <a:ea typeface="Noto Sans SC"/>
+                <a:cs typeface="Noto Sans SC"/>
+              </a:defRPr>
+            </a:pPr>
+            <a:r>
+              <a:rPr sz="2400">
+                <a:solidFill>
+                  <a:srgbClr val="000000"/>
+                </a:solidFill>
+                <a:latin typeface="Noto Sans SC"/>
+                <a:ea typeface="Noto Sans SC"/>
+                <a:cs typeface="Noto Sans SC"/>
+              </a:rPr>
               <a:t>
 校验参数、检查权限、执行工具、记录结果，并决定是否继续循环。</a:t>
             </a:r>
           </a:p>
           <a:p xmlns:a="http://schemas.openxmlformats.org/drawingml/2006/main">
             <a:pPr algn="l">
+              <a:buNone/>
               <a:defRPr sz="2400">
                 <a:solidFill>
                   <a:srgbClr val="000000"/>
@@ -7440,16 +8476,25 @@
           <a:lstStyle xmlns:a="http://schemas.openxmlformats.org/drawingml/2006/main"/>
           <a:p xmlns:a="http://schemas.openxmlformats.org/drawingml/2006/main">
             <a:pPr algn="r">
+              <a:buNone/>
               <a:defRPr sz="1000">
                 <a:solidFill>
                   <a:srgbClr val="000000"/>
                 </a:solidFill>
-                <a:latin typeface="Helvetica Neue"/>
-                <a:ea typeface="Helvetica Neue"/>
-                <a:cs typeface="Helvetica Neue"/>
-              </a:defRPr>
-            </a:pPr>
-            <a:r>
+                <a:latin typeface="Noto Sans SC"/>
+                <a:ea typeface="Noto Sans SC"/>
+                <a:cs typeface="Noto Sans SC"/>
+              </a:defRPr>
+            </a:pPr>
+            <a:r>
+              <a:rPr sz="1000">
+                <a:solidFill>
+                  <a:srgbClr val="000000"/>
+                </a:solidFill>
+                <a:latin typeface="Noto Sans SC"/>
+                <a:ea typeface="Noto Sans SC"/>
+                <a:cs typeface="Noto Sans SC"/>
+              </a:rPr>
               <a:t>7</a:t>
             </a:r>
           </a:p>
@@ -7485,16 +8530,25 @@
           <a:lstStyle xmlns:a="http://schemas.openxmlformats.org/drawingml/2006/main"/>
           <a:p xmlns:a="http://schemas.openxmlformats.org/drawingml/2006/main">
             <a:pPr algn="l">
+              <a:buNone/>
               <a:defRPr sz="2900">
                 <a:solidFill>
                   <a:srgbClr val="000000"/>
                 </a:solidFill>
-                <a:latin typeface="Helvetica Neue"/>
-                <a:ea typeface="Helvetica Neue"/>
-                <a:cs typeface="Helvetica Neue"/>
-              </a:defRPr>
-            </a:pPr>
-            <a:r>
+                <a:latin typeface="Noto Sans SC"/>
+                <a:ea typeface="Noto Sans SC"/>
+                <a:cs typeface="Noto Sans SC"/>
+              </a:defRPr>
+            </a:pPr>
+            <a:r>
+              <a:rPr sz="2900">
+                <a:solidFill>
+                  <a:srgbClr val="000000"/>
+                </a:solidFill>
+                <a:latin typeface="Noto Sans SC"/>
+                <a:ea typeface="Noto Sans SC"/>
+                <a:cs typeface="Noto Sans SC"/>
+              </a:rPr>
               <a:t>工具安全需要三道独立门禁</a:t>
             </a:r>
           </a:p>
@@ -7502,7 +8556,7 @@
       </p:sp>
       <p:cxnSp>
         <p:nvCxnSpPr>
-          <p:cNvPr id="18" name="Google-Shape-2259-p159-4"/>
+          <p:cNvPr id="24" name="Google-Shape-2259-p159-4"/>
           <p:cNvCxnSpPr/>
           <p:nvPr/>
         </p:nvCxnSpPr>
@@ -7662,31 +8716,49 @@
           <a:lstStyle xmlns:a="http://schemas.openxmlformats.org/drawingml/2006/main"/>
           <a:p xmlns:a="http://schemas.openxmlformats.org/drawingml/2006/main">
             <a:pPr algn="l">
+              <a:buNone/>
               <a:defRPr sz="1600">
                 <a:solidFill>
                   <a:srgbClr val="000000"/>
                 </a:solidFill>
-                <a:latin typeface="Helvetica Neue"/>
-                <a:ea typeface="Helvetica Neue"/>
-                <a:cs typeface="Helvetica Neue"/>
-              </a:defRPr>
-            </a:pPr>
-            <a:r>
+                <a:latin typeface="Noto Sans SC"/>
+                <a:ea typeface="Noto Sans SC"/>
+                <a:cs typeface="Noto Sans SC"/>
+              </a:defRPr>
+            </a:pPr>
+            <a:r>
+              <a:rPr sz="1600">
+                <a:solidFill>
+                  <a:srgbClr val="000000"/>
+                </a:solidFill>
+                <a:latin typeface="Noto Sans SC"/>
+                <a:ea typeface="Noto Sans SC"/>
+                <a:cs typeface="Noto Sans SC"/>
+              </a:rPr>
               <a:t>授权与参数</a:t>
             </a:r>
           </a:p>
           <a:p xmlns:a="http://schemas.openxmlformats.org/drawingml/2006/main">
             <a:pPr algn="l">
+              <a:buNone/>
               <a:defRPr sz="1600">
                 <a:solidFill>
                   <a:srgbClr val="000000"/>
                 </a:solidFill>
-                <a:latin typeface="Helvetica Neue"/>
-                <a:ea typeface="Helvetica Neue"/>
-                <a:cs typeface="Helvetica Neue"/>
-              </a:defRPr>
-            </a:pPr>
-            <a:r>
+                <a:latin typeface="Noto Sans SC"/>
+                <a:ea typeface="Noto Sans SC"/>
+                <a:cs typeface="Noto Sans SC"/>
+              </a:defRPr>
+            </a:pPr>
+            <a:r>
+              <a:rPr sz="1600">
+                <a:solidFill>
+                  <a:srgbClr val="000000"/>
+                </a:solidFill>
+                <a:latin typeface="Noto Sans SC"/>
+                <a:ea typeface="Noto Sans SC"/>
+                <a:cs typeface="Noto Sans SC"/>
+              </a:rPr>
               <a:t>
 最小权限、Schema、Allowlist、人工确认</a:t>
             </a:r>
@@ -7752,31 +8824,49 @@
           <a:lstStyle xmlns:a="http://schemas.openxmlformats.org/drawingml/2006/main"/>
           <a:p xmlns:a="http://schemas.openxmlformats.org/drawingml/2006/main">
             <a:pPr algn="l">
+              <a:buNone/>
               <a:defRPr sz="1600">
                 <a:solidFill>
                   <a:srgbClr val="000000"/>
                 </a:solidFill>
-                <a:latin typeface="Helvetica Neue"/>
-                <a:ea typeface="Helvetica Neue"/>
-                <a:cs typeface="Helvetica Neue"/>
-              </a:defRPr>
-            </a:pPr>
-            <a:r>
+                <a:latin typeface="Noto Sans SC"/>
+                <a:ea typeface="Noto Sans SC"/>
+                <a:cs typeface="Noto Sans SC"/>
+              </a:defRPr>
+            </a:pPr>
+            <a:r>
+              <a:rPr sz="1600">
+                <a:solidFill>
+                  <a:srgbClr val="000000"/>
+                </a:solidFill>
+                <a:latin typeface="Noto Sans SC"/>
+                <a:ea typeface="Noto Sans SC"/>
+                <a:cs typeface="Noto Sans SC"/>
+              </a:rPr>
               <a:t>隔离与边界</a:t>
             </a:r>
           </a:p>
           <a:p xmlns:a="http://schemas.openxmlformats.org/drawingml/2006/main">
             <a:pPr algn="l">
+              <a:buNone/>
               <a:defRPr sz="1600">
                 <a:solidFill>
                   <a:srgbClr val="000000"/>
                 </a:solidFill>
-                <a:latin typeface="Helvetica Neue"/>
-                <a:ea typeface="Helvetica Neue"/>
-                <a:cs typeface="Helvetica Neue"/>
-              </a:defRPr>
-            </a:pPr>
-            <a:r>
+                <a:latin typeface="Noto Sans SC"/>
+                <a:ea typeface="Noto Sans SC"/>
+                <a:cs typeface="Noto Sans SC"/>
+              </a:defRPr>
+            </a:pPr>
+            <a:r>
+              <a:rPr sz="1600">
+                <a:solidFill>
+                  <a:srgbClr val="000000"/>
+                </a:solidFill>
+                <a:latin typeface="Noto Sans SC"/>
+                <a:ea typeface="Noto Sans SC"/>
+                <a:cs typeface="Noto Sans SC"/>
+              </a:rPr>
               <a:t>
 超时、Sandbox、并发、幂等与取消</a:t>
             </a:r>
@@ -7842,31 +8932,49 @@
           <a:lstStyle xmlns:a="http://schemas.openxmlformats.org/drawingml/2006/main"/>
           <a:p xmlns:a="http://schemas.openxmlformats.org/drawingml/2006/main">
             <a:pPr algn="l">
+              <a:buNone/>
               <a:defRPr sz="1600">
                 <a:solidFill>
                   <a:srgbClr val="000000"/>
                 </a:solidFill>
-                <a:latin typeface="Helvetica Neue"/>
-                <a:ea typeface="Helvetica Neue"/>
-                <a:cs typeface="Helvetica Neue"/>
-              </a:defRPr>
-            </a:pPr>
-            <a:r>
+                <a:latin typeface="Noto Sans SC"/>
+                <a:ea typeface="Noto Sans SC"/>
+                <a:cs typeface="Noto Sans SC"/>
+              </a:defRPr>
+            </a:pPr>
+            <a:r>
+              <a:rPr sz="1600">
+                <a:solidFill>
+                  <a:srgbClr val="000000"/>
+                </a:solidFill>
+                <a:latin typeface="Noto Sans SC"/>
+                <a:ea typeface="Noto Sans SC"/>
+                <a:cs typeface="Noto Sans SC"/>
+              </a:rPr>
               <a:t>验证与审计</a:t>
             </a:r>
           </a:p>
           <a:p xmlns:a="http://schemas.openxmlformats.org/drawingml/2006/main">
             <a:pPr algn="l">
+              <a:buNone/>
               <a:defRPr sz="1600">
                 <a:solidFill>
                   <a:srgbClr val="000000"/>
                 </a:solidFill>
-                <a:latin typeface="Helvetica Neue"/>
-                <a:ea typeface="Helvetica Neue"/>
-                <a:cs typeface="Helvetica Neue"/>
-              </a:defRPr>
-            </a:pPr>
-            <a:r>
+                <a:latin typeface="Noto Sans SC"/>
+                <a:ea typeface="Noto Sans SC"/>
+                <a:cs typeface="Noto Sans SC"/>
+              </a:defRPr>
+            </a:pPr>
+            <a:r>
+              <a:rPr sz="1600">
+                <a:solidFill>
+                  <a:srgbClr val="000000"/>
+                </a:solidFill>
+                <a:latin typeface="Noto Sans SC"/>
+                <a:ea typeface="Noto Sans SC"/>
+                <a:cs typeface="Noto Sans SC"/>
+              </a:rPr>
               <a:t>
 输出校验、脱敏、Trace、补偿与告警</a:t>
             </a:r>
@@ -7903,16 +9011,25 @@
           <a:lstStyle xmlns:a="http://schemas.openxmlformats.org/drawingml/2006/main"/>
           <a:p xmlns:a="http://schemas.openxmlformats.org/drawingml/2006/main">
             <a:pPr algn="l">
+              <a:buNone/>
               <a:defRPr sz="2400">
                 <a:solidFill>
                   <a:srgbClr val="000000"/>
                 </a:solidFill>
-                <a:latin typeface="Helvetica Neue"/>
-                <a:ea typeface="Helvetica Neue"/>
-                <a:cs typeface="Helvetica Neue"/>
-              </a:defRPr>
-            </a:pPr>
-            <a:r>
+                <a:latin typeface="Noto Sans SC"/>
+                <a:ea typeface="Noto Sans SC"/>
+                <a:cs typeface="Noto Sans SC"/>
+              </a:defRPr>
+            </a:pPr>
+            <a:r>
+              <a:rPr sz="2400">
+                <a:solidFill>
+                  <a:srgbClr val="000000"/>
+                </a:solidFill>
+                <a:latin typeface="Noto Sans SC"/>
+                <a:ea typeface="Noto Sans SC"/>
+                <a:cs typeface="Noto Sans SC"/>
+              </a:rPr>
               <a:t>执行中</a:t>
             </a:r>
           </a:p>
@@ -7948,16 +9065,25 @@
           <a:lstStyle xmlns:a="http://schemas.openxmlformats.org/drawingml/2006/main"/>
           <a:p xmlns:a="http://schemas.openxmlformats.org/drawingml/2006/main">
             <a:pPr algn="l">
+              <a:buNone/>
               <a:defRPr sz="2400">
                 <a:solidFill>
                   <a:srgbClr val="000000"/>
                 </a:solidFill>
-                <a:latin typeface="Helvetica Neue"/>
-                <a:ea typeface="Helvetica Neue"/>
-                <a:cs typeface="Helvetica Neue"/>
-              </a:defRPr>
-            </a:pPr>
-            <a:r>
+                <a:latin typeface="Noto Sans SC"/>
+                <a:ea typeface="Noto Sans SC"/>
+                <a:cs typeface="Noto Sans SC"/>
+              </a:defRPr>
+            </a:pPr>
+            <a:r>
+              <a:rPr sz="2400">
+                <a:solidFill>
+                  <a:srgbClr val="000000"/>
+                </a:solidFill>
+                <a:latin typeface="Noto Sans SC"/>
+                <a:ea typeface="Noto Sans SC"/>
+                <a:cs typeface="Noto Sans SC"/>
+              </a:rPr>
               <a:t>调用前</a:t>
             </a:r>
           </a:p>
@@ -7993,16 +9119,25 @@
           <a:lstStyle xmlns:a="http://schemas.openxmlformats.org/drawingml/2006/main"/>
           <a:p xmlns:a="http://schemas.openxmlformats.org/drawingml/2006/main">
             <a:pPr algn="l">
+              <a:buNone/>
               <a:defRPr sz="2400">
                 <a:solidFill>
                   <a:srgbClr val="000000"/>
                 </a:solidFill>
-                <a:latin typeface="Helvetica Neue"/>
-                <a:ea typeface="Helvetica Neue"/>
-                <a:cs typeface="Helvetica Neue"/>
-              </a:defRPr>
-            </a:pPr>
-            <a:r>
+                <a:latin typeface="Noto Sans SC"/>
+                <a:ea typeface="Noto Sans SC"/>
+                <a:cs typeface="Noto Sans SC"/>
+              </a:defRPr>
+            </a:pPr>
+            <a:r>
+              <a:rPr sz="2400">
+                <a:solidFill>
+                  <a:srgbClr val="000000"/>
+                </a:solidFill>
+                <a:latin typeface="Noto Sans SC"/>
+                <a:ea typeface="Noto Sans SC"/>
+                <a:cs typeface="Noto Sans SC"/>
+              </a:rPr>
               <a:t>执行后</a:t>
             </a:r>
           </a:p>
@@ -8060,16 +9195,25 @@
           <a:lstStyle xmlns:a="http://schemas.openxmlformats.org/drawingml/2006/main"/>
           <a:p xmlns:a="http://schemas.openxmlformats.org/drawingml/2006/main">
             <a:pPr algn="r">
+              <a:buNone/>
               <a:defRPr sz="1000">
                 <a:solidFill>
                   <a:srgbClr val="000000"/>
                 </a:solidFill>
-                <a:latin typeface="Helvetica Neue"/>
-                <a:ea typeface="Helvetica Neue"/>
-                <a:cs typeface="Helvetica Neue"/>
-              </a:defRPr>
-            </a:pPr>
-            <a:r>
+                <a:latin typeface="Noto Sans SC"/>
+                <a:ea typeface="Noto Sans SC"/>
+                <a:cs typeface="Noto Sans SC"/>
+              </a:defRPr>
+            </a:pPr>
+            <a:r>
+              <a:rPr sz="1000">
+                <a:solidFill>
+                  <a:srgbClr val="000000"/>
+                </a:solidFill>
+                <a:latin typeface="Noto Sans SC"/>
+                <a:ea typeface="Noto Sans SC"/>
+                <a:cs typeface="Noto Sans SC"/>
+              </a:rPr>
               <a:t>8</a:t>
             </a:r>
           </a:p>
@@ -8105,16 +9249,25 @@
           <a:lstStyle xmlns:a="http://schemas.openxmlformats.org/drawingml/2006/main"/>
           <a:p xmlns:a="http://schemas.openxmlformats.org/drawingml/2006/main">
             <a:pPr algn="l">
+              <a:buNone/>
               <a:defRPr sz="2900">
                 <a:solidFill>
                   <a:srgbClr val="000000"/>
                 </a:solidFill>
-                <a:latin typeface="Helvetica Neue"/>
-                <a:ea typeface="Helvetica Neue"/>
-                <a:cs typeface="Helvetica Neue"/>
-              </a:defRPr>
-            </a:pPr>
-            <a:r>
+                <a:latin typeface="Noto Sans SC"/>
+                <a:ea typeface="Noto Sans SC"/>
+                <a:cs typeface="Noto Sans SC"/>
+              </a:defRPr>
+            </a:pPr>
+            <a:r>
+              <a:rPr sz="2900">
+                <a:solidFill>
+                  <a:srgbClr val="000000"/>
+                </a:solidFill>
+                <a:latin typeface="Noto Sans SC"/>
+                <a:ea typeface="Noto Sans SC"/>
+                <a:cs typeface="Noto Sans SC"/>
+              </a:rPr>
               <a:t>RAG 质量由完整链路决定</a:t>
             </a:r>
           </a:p>
@@ -8150,16 +9303,25 @@
           <a:lstStyle xmlns:a="http://schemas.openxmlformats.org/drawingml/2006/main"/>
           <a:p xmlns:a="http://schemas.openxmlformats.org/drawingml/2006/main">
             <a:pPr algn="l">
+              <a:buNone/>
               <a:defRPr sz="2400">
                 <a:solidFill>
                   <a:srgbClr val="000000"/>
                 </a:solidFill>
-                <a:latin typeface="Helvetica Neue"/>
-                <a:ea typeface="Helvetica Neue"/>
-                <a:cs typeface="Helvetica Neue"/>
-              </a:defRPr>
-            </a:pPr>
-            <a:r>
+                <a:latin typeface="Noto Sans SC"/>
+                <a:ea typeface="Noto Sans SC"/>
+                <a:cs typeface="Noto Sans SC"/>
+              </a:defRPr>
+            </a:pPr>
+            <a:r>
+              <a:rPr sz="2400">
+                <a:solidFill>
+                  <a:srgbClr val="000000"/>
+                </a:solidFill>
+                <a:latin typeface="Noto Sans SC"/>
+                <a:ea typeface="Noto Sans SC"/>
+                <a:cs typeface="Noto Sans SC"/>
+              </a:rPr>
               <a:t>数据版本与解析</a:t>
             </a:r>
           </a:p>
@@ -8195,16 +9357,25 @@
           <a:lstStyle xmlns:a="http://schemas.openxmlformats.org/drawingml/2006/main"/>
           <a:p xmlns:a="http://schemas.openxmlformats.org/drawingml/2006/main">
             <a:pPr algn="l">
+              <a:buNone/>
               <a:defRPr sz="2400">
                 <a:solidFill>
                   <a:srgbClr val="000000"/>
                 </a:solidFill>
-                <a:latin typeface="Helvetica Neue"/>
-                <a:ea typeface="Helvetica Neue"/>
-                <a:cs typeface="Helvetica Neue"/>
-              </a:defRPr>
-            </a:pPr>
-            <a:r>
+                <a:latin typeface="Noto Sans SC"/>
+                <a:ea typeface="Noto Sans SC"/>
+                <a:cs typeface="Noto Sans SC"/>
+              </a:defRPr>
+            </a:pPr>
+            <a:r>
+              <a:rPr sz="2400">
+                <a:solidFill>
+                  <a:srgbClr val="000000"/>
+                </a:solidFill>
+                <a:latin typeface="Noto Sans SC"/>
+                <a:ea typeface="Noto Sans SC"/>
+                <a:cs typeface="Noto Sans SC"/>
+              </a:rPr>
               <a:t>01</a:t>
             </a:r>
           </a:p>
@@ -8240,16 +9411,25 @@
           <a:lstStyle xmlns:a="http://schemas.openxmlformats.org/drawingml/2006/main"/>
           <a:p xmlns:a="http://schemas.openxmlformats.org/drawingml/2006/main">
             <a:pPr algn="l">
+              <a:buNone/>
               <a:defRPr sz="2400">
                 <a:solidFill>
                   <a:srgbClr val="000000"/>
                 </a:solidFill>
-                <a:latin typeface="Helvetica Neue"/>
-                <a:ea typeface="Helvetica Neue"/>
-                <a:cs typeface="Helvetica Neue"/>
-              </a:defRPr>
-            </a:pPr>
-            <a:r>
+                <a:latin typeface="Noto Sans SC"/>
+                <a:ea typeface="Noto Sans SC"/>
+                <a:cs typeface="Noto Sans SC"/>
+              </a:defRPr>
+            </a:pPr>
+            <a:r>
+              <a:rPr sz="2400">
+                <a:solidFill>
+                  <a:srgbClr val="000000"/>
+                </a:solidFill>
+                <a:latin typeface="Noto Sans SC"/>
+                <a:ea typeface="Noto Sans SC"/>
+                <a:cs typeface="Noto Sans SC"/>
+              </a:rPr>
               <a:t>召回、过滤与重排</a:t>
             </a:r>
           </a:p>
@@ -8285,16 +9465,25 @@
           <a:lstStyle xmlns:a="http://schemas.openxmlformats.org/drawingml/2006/main"/>
           <a:p xmlns:a="http://schemas.openxmlformats.org/drawingml/2006/main">
             <a:pPr algn="l">
+              <a:buNone/>
               <a:defRPr sz="2400">
                 <a:solidFill>
                   <a:srgbClr val="000000"/>
                 </a:solidFill>
-                <a:latin typeface="Helvetica Neue"/>
-                <a:ea typeface="Helvetica Neue"/>
-                <a:cs typeface="Helvetica Neue"/>
-              </a:defRPr>
-            </a:pPr>
-            <a:r>
+                <a:latin typeface="Noto Sans SC"/>
+                <a:ea typeface="Noto Sans SC"/>
+                <a:cs typeface="Noto Sans SC"/>
+              </a:defRPr>
+            </a:pPr>
+            <a:r>
+              <a:rPr sz="2400">
+                <a:solidFill>
+                  <a:srgbClr val="000000"/>
+                </a:solidFill>
+                <a:latin typeface="Noto Sans SC"/>
+                <a:ea typeface="Noto Sans SC"/>
+                <a:cs typeface="Noto Sans SC"/>
+              </a:rPr>
               <a:t>02</a:t>
             </a:r>
           </a:p>
@@ -8330,16 +9519,25 @@
           <a:lstStyle xmlns:a="http://schemas.openxmlformats.org/drawingml/2006/main"/>
           <a:p xmlns:a="http://schemas.openxmlformats.org/drawingml/2006/main">
             <a:pPr algn="l">
+              <a:buNone/>
               <a:defRPr sz="2400">
                 <a:solidFill>
                   <a:srgbClr val="000000"/>
                 </a:solidFill>
-                <a:latin typeface="Helvetica Neue"/>
-                <a:ea typeface="Helvetica Neue"/>
-                <a:cs typeface="Helvetica Neue"/>
-              </a:defRPr>
-            </a:pPr>
-            <a:r>
+                <a:latin typeface="Noto Sans SC"/>
+                <a:ea typeface="Noto Sans SC"/>
+                <a:cs typeface="Noto Sans SC"/>
+              </a:defRPr>
+            </a:pPr>
+            <a:r>
+              <a:rPr sz="2400">
+                <a:solidFill>
+                  <a:srgbClr val="000000"/>
+                </a:solidFill>
+                <a:latin typeface="Noto Sans SC"/>
+                <a:ea typeface="Noto Sans SC"/>
+                <a:cs typeface="Noto Sans SC"/>
+              </a:rPr>
               <a:t>引用上下文与生成</a:t>
             </a:r>
           </a:p>
@@ -8375,16 +9573,25 @@
           <a:lstStyle xmlns:a="http://schemas.openxmlformats.org/drawingml/2006/main"/>
           <a:p xmlns:a="http://schemas.openxmlformats.org/drawingml/2006/main">
             <a:pPr algn="l">
+              <a:buNone/>
               <a:defRPr sz="2400">
                 <a:solidFill>
                   <a:srgbClr val="000000"/>
                 </a:solidFill>
-                <a:latin typeface="Helvetica Neue"/>
-                <a:ea typeface="Helvetica Neue"/>
-                <a:cs typeface="Helvetica Neue"/>
-              </a:defRPr>
-            </a:pPr>
-            <a:r>
+                <a:latin typeface="Noto Sans SC"/>
+                <a:ea typeface="Noto Sans SC"/>
+                <a:cs typeface="Noto Sans SC"/>
+              </a:defRPr>
+            </a:pPr>
+            <a:r>
+              <a:rPr sz="2400">
+                <a:solidFill>
+                  <a:srgbClr val="000000"/>
+                </a:solidFill>
+                <a:latin typeface="Noto Sans SC"/>
+                <a:ea typeface="Noto Sans SC"/>
+                <a:cs typeface="Noto Sans SC"/>
+              </a:rPr>
               <a:t>03</a:t>
             </a:r>
           </a:p>
@@ -8420,16 +9627,25 @@
           <a:lstStyle xmlns:a="http://schemas.openxmlformats.org/drawingml/2006/main"/>
           <a:p xmlns:a="http://schemas.openxmlformats.org/drawingml/2006/main">
             <a:pPr algn="l">
+              <a:buNone/>
               <a:defRPr sz="2400">
                 <a:solidFill>
                   <a:srgbClr val="000000"/>
                 </a:solidFill>
-                <a:latin typeface="Helvetica Neue"/>
-                <a:ea typeface="Helvetica Neue"/>
-                <a:cs typeface="Helvetica Neue"/>
-              </a:defRPr>
-            </a:pPr>
-            <a:r>
+                <a:latin typeface="Noto Sans SC"/>
+                <a:ea typeface="Noto Sans SC"/>
+                <a:cs typeface="Noto Sans SC"/>
+              </a:defRPr>
+            </a:pPr>
+            <a:r>
+              <a:rPr sz="2400">
+                <a:solidFill>
+                  <a:srgbClr val="000000"/>
+                </a:solidFill>
+                <a:latin typeface="Noto Sans SC"/>
+                <a:ea typeface="Noto Sans SC"/>
+                <a:cs typeface="Noto Sans SC"/>
+              </a:rPr>
               <a:t>黄金集与发布门禁</a:t>
             </a:r>
           </a:p>
@@ -8465,16 +9681,25 @@
           <a:lstStyle xmlns:a="http://schemas.openxmlformats.org/drawingml/2006/main"/>
           <a:p xmlns:a="http://schemas.openxmlformats.org/drawingml/2006/main">
             <a:pPr algn="l">
+              <a:buNone/>
               <a:defRPr sz="2400">
                 <a:solidFill>
                   <a:srgbClr val="000000"/>
                 </a:solidFill>
-                <a:latin typeface="Helvetica Neue"/>
-                <a:ea typeface="Helvetica Neue"/>
-                <a:cs typeface="Helvetica Neue"/>
-              </a:defRPr>
-            </a:pPr>
-            <a:r>
+                <a:latin typeface="Noto Sans SC"/>
+                <a:ea typeface="Noto Sans SC"/>
+                <a:cs typeface="Noto Sans SC"/>
+              </a:defRPr>
+            </a:pPr>
+            <a:r>
+              <a:rPr sz="2400">
+                <a:solidFill>
+                  <a:srgbClr val="000000"/>
+                </a:solidFill>
+                <a:latin typeface="Noto Sans SC"/>
+                <a:ea typeface="Noto Sans SC"/>
+                <a:cs typeface="Noto Sans SC"/>
+              </a:rPr>
               <a:t>04</a:t>
             </a:r>
           </a:p>
@@ -8510,37 +9735,56 @@
           <a:lstStyle xmlns:a="http://schemas.openxmlformats.org/drawingml/2006/main"/>
           <a:p xmlns:a="http://schemas.openxmlformats.org/drawingml/2006/main">
             <a:pPr algn="l">
+              <a:buNone/>
               <a:defRPr sz="2400">
                 <a:solidFill>
                   <a:srgbClr val="000000"/>
                 </a:solidFill>
-                <a:latin typeface="Helvetica Neue"/>
-                <a:ea typeface="Helvetica Neue"/>
-                <a:cs typeface="Helvetica Neue"/>
-              </a:defRPr>
-            </a:pPr>
-            <a:r>
+                <a:latin typeface="Noto Sans SC"/>
+                <a:ea typeface="Noto Sans SC"/>
+                <a:cs typeface="Noto Sans SC"/>
+              </a:defRPr>
+            </a:pPr>
+            <a:r>
+              <a:rPr sz="2400">
+                <a:solidFill>
+                  <a:srgbClr val="000000"/>
+                </a:solidFill>
+                <a:latin typeface="Noto Sans SC"/>
+                <a:ea typeface="Noto Sans SC"/>
+                <a:cs typeface="Noto Sans SC"/>
+              </a:rPr>
               <a:t>检索命中不等于回答正确</a:t>
             </a:r>
           </a:p>
           <a:p xmlns:a="http://schemas.openxmlformats.org/drawingml/2006/main">
             <a:pPr algn="l">
+              <a:buNone/>
               <a:defRPr sz="2400">
                 <a:solidFill>
                   <a:srgbClr val="000000"/>
                 </a:solidFill>
-                <a:latin typeface="Helvetica Neue"/>
-                <a:ea typeface="Helvetica Neue"/>
-                <a:cs typeface="Helvetica Neue"/>
-              </a:defRPr>
-            </a:pPr>
-            <a:r>
+                <a:latin typeface="Noto Sans SC"/>
+                <a:ea typeface="Noto Sans SC"/>
+                <a:cs typeface="Noto Sans SC"/>
+              </a:defRPr>
+            </a:pPr>
+            <a:r>
+              <a:rPr sz="2400">
+                <a:solidFill>
+                  <a:srgbClr val="000000"/>
+                </a:solidFill>
+                <a:latin typeface="Noto Sans SC"/>
+                <a:ea typeface="Noto Sans SC"/>
+                <a:cs typeface="Noto Sans SC"/>
+              </a:rPr>
               <a:t>
 数据质量、切分、过滤、重排、上下文组织、生成和引用映射都会失效。</a:t>
             </a:r>
           </a:p>
           <a:p xmlns:a="http://schemas.openxmlformats.org/drawingml/2006/main">
             <a:pPr algn="l">
+              <a:buNone/>
               <a:defRPr sz="2400">
                 <a:solidFill>
                   <a:srgbClr val="000000"/>
@@ -8608,16 +9852,25 @@
           <a:lstStyle xmlns:a="http://schemas.openxmlformats.org/drawingml/2006/main"/>
           <a:p xmlns:a="http://schemas.openxmlformats.org/drawingml/2006/main">
             <a:pPr algn="r">
+              <a:buNone/>
               <a:defRPr sz="1000">
                 <a:solidFill>
                   <a:srgbClr val="000000"/>
                 </a:solidFill>
-                <a:latin typeface="Helvetica Neue"/>
-                <a:ea typeface="Helvetica Neue"/>
-                <a:cs typeface="Helvetica Neue"/>
-              </a:defRPr>
-            </a:pPr>
-            <a:r>
+                <a:latin typeface="Noto Sans SC"/>
+                <a:ea typeface="Noto Sans SC"/>
+                <a:cs typeface="Noto Sans SC"/>
+              </a:defRPr>
+            </a:pPr>
+            <a:r>
+              <a:rPr sz="1000">
+                <a:solidFill>
+                  <a:srgbClr val="000000"/>
+                </a:solidFill>
+                <a:latin typeface="Noto Sans SC"/>
+                <a:ea typeface="Noto Sans SC"/>
+                <a:cs typeface="Noto Sans SC"/>
+              </a:rPr>
               <a:t>9</a:t>
             </a:r>
           </a:p>
@@ -8653,16 +9906,25 @@
           <a:lstStyle xmlns:a="http://schemas.openxmlformats.org/drawingml/2006/main"/>
           <a:p xmlns:a="http://schemas.openxmlformats.org/drawingml/2006/main">
             <a:pPr algn="l">
+              <a:buNone/>
               <a:defRPr sz="2900">
                 <a:solidFill>
                   <a:srgbClr val="000000"/>
                 </a:solidFill>
-                <a:latin typeface="Helvetica Neue"/>
-                <a:ea typeface="Helvetica Neue"/>
-                <a:cs typeface="Helvetica Neue"/>
-              </a:defRPr>
-            </a:pPr>
-            <a:r>
+                <a:latin typeface="Noto Sans SC"/>
+                <a:ea typeface="Noto Sans SC"/>
+                <a:cs typeface="Noto Sans SC"/>
+              </a:defRPr>
+            </a:pPr>
+            <a:r>
+              <a:rPr sz="2900">
+                <a:solidFill>
+                  <a:srgbClr val="000000"/>
+                </a:solidFill>
+                <a:latin typeface="Noto Sans SC"/>
+                <a:ea typeface="Noto Sans SC"/>
+                <a:cs typeface="Noto Sans SC"/>
+              </a:rPr>
               <a:t>RAG 与 Memory 可以共用技术，但服务不同语义</a:t>
             </a:r>
           </a:p>
@@ -8698,31 +9960,49 @@
           <a:lstStyle xmlns:a="http://schemas.openxmlformats.org/drawingml/2006/main"/>
           <a:p xmlns:a="http://schemas.openxmlformats.org/drawingml/2006/main">
             <a:pPr algn="l">
+              <a:buNone/>
               <a:defRPr sz="2400">
                 <a:solidFill>
                   <a:srgbClr val="000000"/>
                 </a:solidFill>
-                <a:latin typeface="Helvetica Neue"/>
-                <a:ea typeface="Helvetica Neue"/>
-                <a:cs typeface="Helvetica Neue"/>
-              </a:defRPr>
-            </a:pPr>
-            <a:r>
+                <a:latin typeface="Noto Sans SC"/>
+                <a:ea typeface="Noto Sans SC"/>
+                <a:cs typeface="Noto Sans SC"/>
+              </a:defRPr>
+            </a:pPr>
+            <a:r>
+              <a:rPr sz="2400">
+                <a:solidFill>
+                  <a:srgbClr val="000000"/>
+                </a:solidFill>
+                <a:latin typeface="Noto Sans SC"/>
+                <a:ea typeface="Noto Sans SC"/>
+                <a:cs typeface="Noto Sans SC"/>
+              </a:rPr>
               <a:t>RAG：外部知识</a:t>
             </a:r>
           </a:p>
           <a:p xmlns:a="http://schemas.openxmlformats.org/drawingml/2006/main">
             <a:pPr algn="l">
+              <a:buNone/>
               <a:defRPr sz="2400">
                 <a:solidFill>
                   <a:srgbClr val="000000"/>
                 </a:solidFill>
-                <a:latin typeface="Helvetica Neue"/>
-                <a:ea typeface="Helvetica Neue"/>
-                <a:cs typeface="Helvetica Neue"/>
-              </a:defRPr>
-            </a:pPr>
-            <a:r>
+                <a:latin typeface="Noto Sans SC"/>
+                <a:ea typeface="Noto Sans SC"/>
+                <a:cs typeface="Noto Sans SC"/>
+              </a:defRPr>
+            </a:pPr>
+            <a:r>
+              <a:rPr sz="2400">
+                <a:solidFill>
+                  <a:srgbClr val="000000"/>
+                </a:solidFill>
+                <a:latin typeface="Noto Sans SC"/>
+                <a:ea typeface="Noto Sans SC"/>
+                <a:cs typeface="Noto Sans SC"/>
+              </a:rPr>
               <a:t>
 面向文档、规范和事实；重点是版本、权限、召回、引用与删除。</a:t>
             </a:r>
@@ -8759,31 +10039,49 @@
           <a:lstStyle xmlns:a="http://schemas.openxmlformats.org/drawingml/2006/main"/>
           <a:p xmlns:a="http://schemas.openxmlformats.org/drawingml/2006/main">
             <a:pPr algn="l">
+              <a:buNone/>
               <a:defRPr sz="2400">
                 <a:solidFill>
                   <a:srgbClr val="000000"/>
                 </a:solidFill>
-                <a:latin typeface="Helvetica Neue"/>
-                <a:ea typeface="Helvetica Neue"/>
-                <a:cs typeface="Helvetica Neue"/>
-              </a:defRPr>
-            </a:pPr>
-            <a:r>
+                <a:latin typeface="Noto Sans SC"/>
+                <a:ea typeface="Noto Sans SC"/>
+                <a:cs typeface="Noto Sans SC"/>
+              </a:defRPr>
+            </a:pPr>
+            <a:r>
+              <a:rPr sz="2400">
+                <a:solidFill>
+                  <a:srgbClr val="000000"/>
+                </a:solidFill>
+                <a:latin typeface="Noto Sans SC"/>
+                <a:ea typeface="Noto Sans SC"/>
+                <a:cs typeface="Noto Sans SC"/>
+              </a:rPr>
               <a:t>Memory：主体经历</a:t>
             </a:r>
           </a:p>
           <a:p xmlns:a="http://schemas.openxmlformats.org/drawingml/2006/main">
             <a:pPr algn="l">
+              <a:buNone/>
               <a:defRPr sz="2400">
                 <a:solidFill>
                   <a:srgbClr val="000000"/>
                 </a:solidFill>
-                <a:latin typeface="Helvetica Neue"/>
-                <a:ea typeface="Helvetica Neue"/>
-                <a:cs typeface="Helvetica Neue"/>
-              </a:defRPr>
-            </a:pPr>
-            <a:r>
+                <a:latin typeface="Noto Sans SC"/>
+                <a:ea typeface="Noto Sans SC"/>
+                <a:cs typeface="Noto Sans SC"/>
+              </a:defRPr>
+            </a:pPr>
+            <a:r>
+              <a:rPr sz="2400">
+                <a:solidFill>
+                  <a:srgbClr val="000000"/>
+                </a:solidFill>
+                <a:latin typeface="Noto Sans SC"/>
+                <a:ea typeface="Noto Sans SC"/>
+                <a:cs typeface="Noto Sans SC"/>
+              </a:rPr>
               <a:t>
 面向会话、偏好与事件；重点是写入资格、遗忘、隐私和用户控制。</a:t>
             </a:r>

</xml_diff>